<commit_message>
library section: v1's fixed-layout skeleton, after the logic slide
The library slide returns to the default deck as a content skeleton
imported from deck/skeletons/_shared/library.pptx (copied to
assets/reference/ with its sidecar), replacing the company template's
slide 10 in the registry. One required image hole — this run's Library
screen — no tokens; the _fix_library_subtitle fixup still applies (same
subtitle box). Spec places it between the inspection-logic slide and the
closing run.

Live on the Traton run: matched 12_library.png, rendered verbatim with
the run's capture browser in the hole, 15 slides, 0 errors.

Co-Authored-By: Claude Fable 5 <noreply@anthropic.com>
</commit_message>
<xml_diff>
--- a/skills/overview-deck/assets/skeletons/library.pptx
+++ b/skills/overview-deck/assets/skeletons/library.pptx
@@ -712,7 +712,7 @@
     </p:bg>
     <p:spTree>
       <p:nvGrpSpPr>
-        <p:cNvPr id="80" name="Shape 80"/>
+        <p:cNvPr id="91" name="Shape 91"/>
         <p:cNvGrpSpPr/>
         <p:nvPr/>
       </p:nvGrpSpPr>
@@ -726,7 +726,7 @@
       </p:grpSpPr>
       <p:sp>
         <p:nvSpPr>
-          <p:cNvPr id="81" name="Google Shape;81;p15"/>
+          <p:cNvPr id="92" name="Google Shape;92;p17"/>
           <p:cNvSpPr txBox="1"/>
           <p:nvPr>
             <p:ph type="title"/>
@@ -735,7 +735,7 @@
         <p:spPr>
           <a:xfrm>
             <a:off x="369989" y="554985"/>
-            <a:ext cx="11451715" cy="1179972"/>
+            <a:ext cx="11451714" cy="1179970"/>
           </a:xfrm>
           <a:prstGeom prst="rect">
             <a:avLst/>
@@ -914,7 +914,7 @@
       </p:sp>
       <p:sp>
         <p:nvSpPr>
-          <p:cNvPr id="82" name="Google Shape;82;p15"/>
+          <p:cNvPr id="93" name="Google Shape;93;p17"/>
           <p:cNvSpPr txBox="1"/>
           <p:nvPr>
             <p:ph idx="1" type="body"/>
@@ -923,7 +923,7 @@
         <p:spPr>
           <a:xfrm>
             <a:off x="369989" y="371791"/>
-            <a:ext cx="5110275" cy="183197"/>
+            <a:ext cx="5110272" cy="183195"/>
           </a:xfrm>
           <a:prstGeom prst="rect">
             <a:avLst/>
@@ -1110,7 +1110,7 @@
       </p:sp>
       <p:sp>
         <p:nvSpPr>
-          <p:cNvPr id="83" name="Google Shape;83;p15"/>
+          <p:cNvPr id="94" name="Google Shape;94;p17"/>
           <p:cNvSpPr txBox="1"/>
           <p:nvPr>
             <p:ph idx="12" type="sldNum"/>
@@ -1119,7 +1119,7 @@
         <p:spPr>
           <a:xfrm>
             <a:off x="11652438" y="6343529"/>
-            <a:ext cx="169330" cy="169330"/>
+            <a:ext cx="169196" cy="163996"/>
           </a:xfrm>
           <a:prstGeom prst="rect">
             <a:avLst/>
@@ -1407,7 +1407,7 @@
     </p:bg>
     <p:spTree>
       <p:nvGrpSpPr>
-        <p:cNvPr id="54" name="Shape 54"/>
+        <p:cNvPr id="65" name="Shape 65"/>
         <p:cNvGrpSpPr/>
         <p:nvPr/>
       </p:nvGrpSpPr>
@@ -1421,7 +1421,7 @@
       </p:grpSpPr>
       <p:sp>
         <p:nvSpPr>
-          <p:cNvPr id="55" name="Google Shape;55;p14"/>
+          <p:cNvPr id="66" name="Google Shape;66;p16"/>
           <p:cNvSpPr txBox="1"/>
           <p:nvPr>
             <p:ph type="title"/>
@@ -1605,14 +1605,14 @@
       </p:sp>
       <p:sp>
         <p:nvSpPr>
-          <p:cNvPr id="56" name="Google Shape;56;p14"/>
+          <p:cNvPr id="67" name="Google Shape;67;p16"/>
           <p:cNvSpPr/>
           <p:nvPr/>
         </p:nvSpPr>
         <p:spPr>
           <a:xfrm>
             <a:off x="6108981" y="0"/>
-            <a:ext cx="6082649" cy="6857828"/>
+            <a:ext cx="6082648" cy="6857828"/>
           </a:xfrm>
           <a:prstGeom prst="rect">
             <a:avLst/>
@@ -1626,7 +1626,7 @@
                 <a:srgbClr val="493691"/>
               </a:gs>
             </a:gsLst>
-            <a:lin ang="16198661" scaled="0"/>
+            <a:lin ang="16198662" scaled="0"/>
           </a:gradFill>
           <a:ln>
             <a:noFill/>
@@ -1672,7 +1672,7 @@
       </p:sp>
       <p:sp>
         <p:nvSpPr>
-          <p:cNvPr id="57" name="Google Shape;57;p14"/>
+          <p:cNvPr id="68" name="Google Shape;68;p16"/>
           <p:cNvSpPr txBox="1"/>
           <p:nvPr>
             <p:ph idx="1" type="body"/>
@@ -1681,7 +1681,7 @@
         <p:spPr>
           <a:xfrm>
             <a:off x="369989" y="371791"/>
-            <a:ext cx="5110275" cy="183197"/>
+            <a:ext cx="5110272" cy="183195"/>
           </a:xfrm>
           <a:prstGeom prst="rect">
             <a:avLst/>
@@ -1868,14 +1868,14 @@
       </p:sp>
       <p:cxnSp>
         <p:nvCxnSpPr>
-          <p:cNvPr id="58" name="Google Shape;58;p14"/>
+          <p:cNvPr id="69" name="Google Shape;69;p16"/>
           <p:cNvCxnSpPr/>
           <p:nvPr/>
         </p:nvCxnSpPr>
         <p:spPr>
           <a:xfrm rot="10800000">
-            <a:off x="6113894" y="1770222"/>
-            <a:ext cx="6082649" cy="1"/>
+            <a:off x="6113895" y="1770224"/>
+            <a:ext cx="6082648" cy="0"/>
           </a:xfrm>
           <a:prstGeom prst="straightConnector1">
             <a:avLst/>
@@ -1894,14 +1894,14 @@
       </p:cxnSp>
       <p:cxnSp>
         <p:nvCxnSpPr>
-          <p:cNvPr id="59" name="Google Shape;59;p14"/>
+          <p:cNvPr id="70" name="Google Shape;70;p16"/>
           <p:cNvCxnSpPr/>
           <p:nvPr/>
         </p:nvCxnSpPr>
         <p:spPr>
           <a:xfrm rot="10800000">
-            <a:off x="6113894" y="2419557"/>
-            <a:ext cx="6082649" cy="1"/>
+            <a:off x="6113895" y="2419558"/>
+            <a:ext cx="6082648" cy="0"/>
           </a:xfrm>
           <a:prstGeom prst="straightConnector1">
             <a:avLst/>
@@ -1920,14 +1920,14 @@
       </p:cxnSp>
       <p:cxnSp>
         <p:nvCxnSpPr>
-          <p:cNvPr id="60" name="Google Shape;60;p14"/>
+          <p:cNvPr id="71" name="Google Shape;71;p16"/>
           <p:cNvCxnSpPr/>
           <p:nvPr/>
         </p:nvCxnSpPr>
         <p:spPr>
           <a:xfrm rot="10800000">
-            <a:off x="6113894" y="3068961"/>
-            <a:ext cx="6082649" cy="1"/>
+            <a:off x="6113895" y="3068962"/>
+            <a:ext cx="6082648" cy="0"/>
           </a:xfrm>
           <a:prstGeom prst="straightConnector1">
             <a:avLst/>
@@ -1946,14 +1946,14 @@
       </p:cxnSp>
       <p:cxnSp>
         <p:nvCxnSpPr>
-          <p:cNvPr id="61" name="Google Shape;61;p14"/>
+          <p:cNvPr id="72" name="Google Shape;72;p16"/>
           <p:cNvCxnSpPr/>
           <p:nvPr/>
         </p:nvCxnSpPr>
         <p:spPr>
           <a:xfrm rot="10800000">
-            <a:off x="6113894" y="3718360"/>
-            <a:ext cx="6082649" cy="1"/>
+            <a:off x="6113895" y="3718362"/>
+            <a:ext cx="6082648" cy="0"/>
           </a:xfrm>
           <a:prstGeom prst="straightConnector1">
             <a:avLst/>
@@ -1972,14 +1972,14 @@
       </p:cxnSp>
       <p:cxnSp>
         <p:nvCxnSpPr>
-          <p:cNvPr id="62" name="Google Shape;62;p14"/>
+          <p:cNvPr id="73" name="Google Shape;73;p16"/>
           <p:cNvCxnSpPr/>
           <p:nvPr/>
         </p:nvCxnSpPr>
         <p:spPr>
           <a:xfrm rot="10800000">
-            <a:off x="6113894" y="4367765"/>
-            <a:ext cx="6082649" cy="1"/>
+            <a:off x="6113895" y="4367767"/>
+            <a:ext cx="6082648" cy="0"/>
           </a:xfrm>
           <a:prstGeom prst="straightConnector1">
             <a:avLst/>
@@ -1998,14 +1998,14 @@
       </p:cxnSp>
       <p:cxnSp>
         <p:nvCxnSpPr>
-          <p:cNvPr id="63" name="Google Shape;63;p14"/>
+          <p:cNvPr id="74" name="Google Shape;74;p16"/>
           <p:cNvCxnSpPr/>
           <p:nvPr/>
         </p:nvCxnSpPr>
         <p:spPr>
           <a:xfrm rot="10800000">
-            <a:off x="6113894" y="5017097"/>
-            <a:ext cx="6082649" cy="1"/>
+            <a:off x="6113895" y="5017098"/>
+            <a:ext cx="6082648" cy="0"/>
           </a:xfrm>
           <a:prstGeom prst="straightConnector1">
             <a:avLst/>
@@ -2024,14 +2024,14 @@
       </p:cxnSp>
       <p:cxnSp>
         <p:nvCxnSpPr>
-          <p:cNvPr id="64" name="Google Shape;64;p14"/>
+          <p:cNvPr id="75" name="Google Shape;75;p16"/>
           <p:cNvCxnSpPr/>
           <p:nvPr/>
         </p:nvCxnSpPr>
         <p:spPr>
           <a:xfrm rot="10800000">
-            <a:off x="6113894" y="5666502"/>
-            <a:ext cx="6082649" cy="1"/>
+            <a:off x="6113895" y="5666504"/>
+            <a:ext cx="6082648" cy="0"/>
           </a:xfrm>
           <a:prstGeom prst="straightConnector1">
             <a:avLst/>
@@ -2050,14 +2050,14 @@
       </p:cxnSp>
       <p:cxnSp>
         <p:nvCxnSpPr>
-          <p:cNvPr id="65" name="Google Shape;65;p14"/>
+          <p:cNvPr id="76" name="Google Shape;76;p16"/>
           <p:cNvCxnSpPr/>
           <p:nvPr/>
         </p:nvCxnSpPr>
         <p:spPr>
           <a:xfrm rot="10800000">
-            <a:off x="6113894" y="6315802"/>
-            <a:ext cx="6082649" cy="1"/>
+            <a:off x="6113895" y="6315803"/>
+            <a:ext cx="6082648" cy="0"/>
           </a:xfrm>
           <a:prstGeom prst="straightConnector1">
             <a:avLst/>
@@ -2076,14 +2076,14 @@
       </p:cxnSp>
       <p:cxnSp>
         <p:nvCxnSpPr>
-          <p:cNvPr id="66" name="Google Shape;66;p14"/>
+          <p:cNvPr id="77" name="Google Shape;77;p16"/>
           <p:cNvCxnSpPr/>
           <p:nvPr/>
         </p:nvCxnSpPr>
         <p:spPr>
           <a:xfrm rot="10800000">
-            <a:off x="6113894" y="471415"/>
-            <a:ext cx="6082649" cy="1"/>
+            <a:off x="6113895" y="471416"/>
+            <a:ext cx="6082648" cy="0"/>
           </a:xfrm>
           <a:prstGeom prst="straightConnector1">
             <a:avLst/>
@@ -2102,14 +2102,14 @@
       </p:cxnSp>
       <p:cxnSp>
         <p:nvCxnSpPr>
-          <p:cNvPr id="67" name="Google Shape;67;p14"/>
+          <p:cNvPr id="78" name="Google Shape;78;p16"/>
           <p:cNvCxnSpPr/>
           <p:nvPr/>
         </p:nvCxnSpPr>
         <p:spPr>
           <a:xfrm rot="10800000">
-            <a:off x="6113894" y="1120819"/>
-            <a:ext cx="6082649" cy="1"/>
+            <a:off x="6113895" y="1120820"/>
+            <a:ext cx="6082648" cy="0"/>
           </a:xfrm>
           <a:prstGeom prst="straightConnector1">
             <a:avLst/>
@@ -2128,28 +2128,28 @@
       </p:cxnSp>
       <p:grpSp>
         <p:nvGrpSpPr>
-          <p:cNvPr id="68" name="Google Shape;68;p14"/>
+          <p:cNvPr id="79" name="Google Shape;79;p16"/>
           <p:cNvGrpSpPr/>
           <p:nvPr/>
         </p:nvGrpSpPr>
         <p:grpSpPr>
           <a:xfrm>
-            <a:off x="6115350" y="-136"/>
-            <a:ext cx="5783159" cy="6857896"/>
-            <a:chOff x="-1" y="0"/>
-            <a:chExt cx="5783158" cy="6857894"/>
+            <a:off x="6115352" y="-136"/>
+            <a:ext cx="5783155" cy="6857828"/>
+            <a:chOff x="1" y="0"/>
+            <a:chExt cx="5783155" cy="6857828"/>
           </a:xfrm>
         </p:grpSpPr>
         <p:cxnSp>
           <p:nvCxnSpPr>
-            <p:cNvPr id="69" name="Google Shape;69;p14"/>
+            <p:cNvPr id="80" name="Google Shape;80;p16"/>
             <p:cNvCxnSpPr/>
             <p:nvPr/>
           </p:nvCxnSpPr>
           <p:spPr>
-            <a:xfrm flipH="1">
-              <a:off x="-1" y="0"/>
-              <a:ext cx="3" cy="6857894"/>
+            <a:xfrm>
+              <a:off x="1" y="0"/>
+              <a:ext cx="0" cy="6857828"/>
             </a:xfrm>
             <a:prstGeom prst="straightConnector1">
               <a:avLst/>
@@ -2168,14 +2168,14 @@
         </p:cxnSp>
         <p:cxnSp>
           <p:nvCxnSpPr>
-            <p:cNvPr id="70" name="Google Shape;70;p14"/>
+            <p:cNvPr id="81" name="Google Shape;81;p16"/>
             <p:cNvCxnSpPr/>
             <p:nvPr/>
           </p:nvCxnSpPr>
           <p:spPr>
-            <a:xfrm flipH="1">
-              <a:off x="642536" y="0"/>
-              <a:ext cx="1" cy="6857894"/>
+            <a:xfrm>
+              <a:off x="642537" y="0"/>
+              <a:ext cx="0" cy="6857828"/>
             </a:xfrm>
             <a:prstGeom prst="straightConnector1">
               <a:avLst/>
@@ -2194,14 +2194,14 @@
         </p:cxnSp>
         <p:cxnSp>
           <p:nvCxnSpPr>
-            <p:cNvPr id="71" name="Google Shape;71;p14"/>
+            <p:cNvPr id="82" name="Google Shape;82;p16"/>
             <p:cNvCxnSpPr/>
             <p:nvPr/>
           </p:nvCxnSpPr>
           <p:spPr>
-            <a:xfrm flipH="1">
-              <a:off x="1285073" y="0"/>
-              <a:ext cx="1" cy="6857894"/>
+            <a:xfrm>
+              <a:off x="1285075" y="0"/>
+              <a:ext cx="0" cy="6857828"/>
             </a:xfrm>
             <a:prstGeom prst="straightConnector1">
               <a:avLst/>
@@ -2220,14 +2220,14 @@
         </p:cxnSp>
         <p:cxnSp>
           <p:nvCxnSpPr>
-            <p:cNvPr id="72" name="Google Shape;72;p14"/>
+            <p:cNvPr id="83" name="Google Shape;83;p16"/>
             <p:cNvCxnSpPr/>
             <p:nvPr/>
           </p:nvCxnSpPr>
           <p:spPr>
-            <a:xfrm flipH="1">
-              <a:off x="1927610" y="0"/>
-              <a:ext cx="1" cy="6857894"/>
+            <a:xfrm>
+              <a:off x="1927612" y="0"/>
+              <a:ext cx="0" cy="6857828"/>
             </a:xfrm>
             <a:prstGeom prst="straightConnector1">
               <a:avLst/>
@@ -2246,14 +2246,14 @@
         </p:cxnSp>
         <p:cxnSp>
           <p:nvCxnSpPr>
-            <p:cNvPr id="73" name="Google Shape;73;p14"/>
+            <p:cNvPr id="84" name="Google Shape;84;p16"/>
             <p:cNvCxnSpPr/>
             <p:nvPr/>
           </p:nvCxnSpPr>
           <p:spPr>
-            <a:xfrm flipH="1">
-              <a:off x="2570146" y="0"/>
-              <a:ext cx="1" cy="6857894"/>
+            <a:xfrm>
+              <a:off x="2570148" y="0"/>
+              <a:ext cx="0" cy="6857828"/>
             </a:xfrm>
             <a:prstGeom prst="straightConnector1">
               <a:avLst/>
@@ -2272,14 +2272,14 @@
         </p:cxnSp>
         <p:cxnSp>
           <p:nvCxnSpPr>
-            <p:cNvPr id="74" name="Google Shape;74;p14"/>
+            <p:cNvPr id="85" name="Google Shape;85;p16"/>
             <p:cNvCxnSpPr/>
             <p:nvPr/>
           </p:nvCxnSpPr>
           <p:spPr>
-            <a:xfrm flipH="1">
-              <a:off x="3212684" y="0"/>
-              <a:ext cx="1" cy="6857894"/>
+            <a:xfrm>
+              <a:off x="3212685" y="0"/>
+              <a:ext cx="0" cy="6857828"/>
             </a:xfrm>
             <a:prstGeom prst="straightConnector1">
               <a:avLst/>
@@ -2298,14 +2298,14 @@
         </p:cxnSp>
         <p:cxnSp>
           <p:nvCxnSpPr>
-            <p:cNvPr id="75" name="Google Shape;75;p14"/>
+            <p:cNvPr id="86" name="Google Shape;86;p16"/>
             <p:cNvCxnSpPr/>
             <p:nvPr/>
           </p:nvCxnSpPr>
           <p:spPr>
-            <a:xfrm flipH="1">
-              <a:off x="3855328" y="0"/>
-              <a:ext cx="1" cy="6857894"/>
+            <a:xfrm>
+              <a:off x="3855329" y="0"/>
+              <a:ext cx="0" cy="6857828"/>
             </a:xfrm>
             <a:prstGeom prst="straightConnector1">
               <a:avLst/>
@@ -2324,14 +2324,14 @@
         </p:cxnSp>
         <p:cxnSp>
           <p:nvCxnSpPr>
-            <p:cNvPr id="76" name="Google Shape;76;p14"/>
+            <p:cNvPr id="87" name="Google Shape;87;p16"/>
             <p:cNvCxnSpPr/>
             <p:nvPr/>
           </p:nvCxnSpPr>
           <p:spPr>
-            <a:xfrm flipH="1">
-              <a:off x="4497863" y="0"/>
-              <a:ext cx="1" cy="6857894"/>
+            <a:xfrm>
+              <a:off x="4497865" y="0"/>
+              <a:ext cx="0" cy="6857828"/>
             </a:xfrm>
             <a:prstGeom prst="straightConnector1">
               <a:avLst/>
@@ -2350,14 +2350,14 @@
         </p:cxnSp>
         <p:cxnSp>
           <p:nvCxnSpPr>
-            <p:cNvPr id="77" name="Google Shape;77;p14"/>
+            <p:cNvPr id="88" name="Google Shape;88;p16"/>
             <p:cNvCxnSpPr/>
             <p:nvPr/>
           </p:nvCxnSpPr>
           <p:spPr>
-            <a:xfrm flipH="1">
-              <a:off x="5140522" y="0"/>
-              <a:ext cx="1" cy="6857894"/>
+            <a:xfrm>
+              <a:off x="5140523" y="0"/>
+              <a:ext cx="0" cy="6857828"/>
             </a:xfrm>
             <a:prstGeom prst="straightConnector1">
               <a:avLst/>
@@ -2376,14 +2376,14 @@
         </p:cxnSp>
         <p:cxnSp>
           <p:nvCxnSpPr>
-            <p:cNvPr id="78" name="Google Shape;78;p14"/>
+            <p:cNvPr id="89" name="Google Shape;89;p16"/>
             <p:cNvCxnSpPr/>
             <p:nvPr/>
           </p:nvCxnSpPr>
           <p:spPr>
-            <a:xfrm flipH="1">
-              <a:off x="5783155" y="0"/>
-              <a:ext cx="1" cy="6857894"/>
+            <a:xfrm>
+              <a:off x="5783157" y="0"/>
+              <a:ext cx="0" cy="6857828"/>
             </a:xfrm>
             <a:prstGeom prst="straightConnector1">
               <a:avLst/>
@@ -2403,7 +2403,7 @@
       </p:grpSp>
       <p:sp>
         <p:nvSpPr>
-          <p:cNvPr id="79" name="Google Shape;79;p14"/>
+          <p:cNvPr id="90" name="Google Shape;90;p16"/>
           <p:cNvSpPr txBox="1"/>
           <p:nvPr>
             <p:ph idx="12" type="sldNum"/>
@@ -2412,7 +2412,7 @@
         <p:spPr>
           <a:xfrm>
             <a:off x="5892653" y="6169928"/>
-            <a:ext cx="2844729" cy="372525"/>
+            <a:ext cx="2844729" cy="369191"/>
           </a:xfrm>
           <a:prstGeom prst="rect">
             <a:avLst/>
@@ -2657,7 +2657,7 @@
   <p:cSld name="CUSTOM_11">
     <p:spTree>
       <p:nvGrpSpPr>
-        <p:cNvPr id="177" name="Shape 177"/>
+        <p:cNvPr id="188" name="Shape 188"/>
         <p:cNvGrpSpPr/>
         <p:nvPr/>
       </p:nvGrpSpPr>
@@ -2671,7 +2671,7 @@
       </p:grpSpPr>
       <p:sp>
         <p:nvSpPr>
-          <p:cNvPr id="178" name="Google Shape;178;p23"/>
+          <p:cNvPr id="189" name="Google Shape;189;p25"/>
           <p:cNvSpPr/>
           <p:nvPr>
             <p:ph idx="2" type="pic"/>
@@ -2680,7 +2680,7 @@
         <p:spPr>
           <a:xfrm>
             <a:off x="369989" y="979441"/>
-            <a:ext cx="1845155" cy="2213546"/>
+            <a:ext cx="1845154" cy="2213545"/>
           </a:xfrm>
           <a:prstGeom prst="rect">
             <a:avLst/>
@@ -2693,7 +2693,7 @@
       </p:sp>
       <p:sp>
         <p:nvSpPr>
-          <p:cNvPr id="179" name="Google Shape;179;p23"/>
+          <p:cNvPr id="190" name="Google Shape;190;p25"/>
           <p:cNvSpPr/>
           <p:nvPr>
             <p:ph idx="3" type="pic"/>
@@ -2702,7 +2702,7 @@
         <p:spPr>
           <a:xfrm>
             <a:off x="369989" y="3361481"/>
-            <a:ext cx="1845155" cy="2505540"/>
+            <a:ext cx="1845154" cy="2505537"/>
           </a:xfrm>
           <a:prstGeom prst="rect">
             <a:avLst/>
@@ -2715,7 +2715,7 @@
       </p:sp>
       <p:sp>
         <p:nvSpPr>
-          <p:cNvPr id="180" name="Google Shape;180;p23"/>
+          <p:cNvPr id="191" name="Google Shape;191;p25"/>
           <p:cNvSpPr/>
           <p:nvPr>
             <p:ph idx="4" type="pic"/>
@@ -2724,7 +2724,7 @@
         <p:spPr>
           <a:xfrm>
             <a:off x="2490115" y="1134505"/>
-            <a:ext cx="3452315" cy="4577485"/>
+            <a:ext cx="3452314" cy="4577485"/>
           </a:xfrm>
           <a:prstGeom prst="rect">
             <a:avLst/>
@@ -2737,7 +2737,7 @@
       </p:sp>
       <p:sp>
         <p:nvSpPr>
-          <p:cNvPr id="181" name="Google Shape;181;p23"/>
+          <p:cNvPr id="192" name="Google Shape;192;p25"/>
           <p:cNvSpPr txBox="1"/>
           <p:nvPr>
             <p:ph type="title"/>
@@ -2746,7 +2746,7 @@
         <p:spPr>
           <a:xfrm>
             <a:off x="7704039" y="2400939"/>
-            <a:ext cx="3760707" cy="1364767"/>
+            <a:ext cx="3760706" cy="1364766"/>
           </a:xfrm>
           <a:prstGeom prst="rect">
             <a:avLst/>
@@ -2926,7 +2926,7 @@
       </p:sp>
       <p:sp>
         <p:nvSpPr>
-          <p:cNvPr id="182" name="Google Shape;182;p23"/>
+          <p:cNvPr id="193" name="Google Shape;193;p25"/>
           <p:cNvSpPr txBox="1"/>
           <p:nvPr>
             <p:ph idx="1" type="body"/>
@@ -2935,7 +2935,7 @@
         <p:spPr>
           <a:xfrm>
             <a:off x="369989" y="371791"/>
-            <a:ext cx="5110275" cy="183197"/>
+            <a:ext cx="5110272" cy="183195"/>
           </a:xfrm>
           <a:prstGeom prst="rect">
             <a:avLst/>
@@ -3102,7 +3102,7 @@
       </p:sp>
       <p:pic>
         <p:nvPicPr>
-          <p:cNvPr descr="Logo-white.pngGoogle Shape;125;p10" id="183" name="Google Shape;183;p23"/>
+          <p:cNvPr descr="Logo-white.pngGoogle Shape;125;p10" id="194" name="Google Shape;194;p25"/>
           <p:cNvPicPr preferRelativeResize="0"/>
           <p:nvPr/>
         </p:nvPicPr>
@@ -3129,7 +3129,7 @@
       </p:pic>
       <p:sp>
         <p:nvSpPr>
-          <p:cNvPr id="184" name="Google Shape;184;p23"/>
+          <p:cNvPr id="195" name="Google Shape;195;p25"/>
           <p:cNvSpPr txBox="1"/>
           <p:nvPr>
             <p:ph idx="12" type="sldNum"/>
@@ -3138,7 +3138,7 @@
         <p:spPr>
           <a:xfrm>
             <a:off x="11652438" y="6343529"/>
-            <a:ext cx="169330" cy="169330"/>
+            <a:ext cx="169196" cy="163996"/>
           </a:xfrm>
           <a:prstGeom prst="rect">
             <a:avLst/>
@@ -3426,7 +3426,7 @@
     </p:bg>
     <p:spTree>
       <p:nvGrpSpPr>
-        <p:cNvPr id="185" name="Shape 185"/>
+        <p:cNvPr id="196" name="Shape 196"/>
         <p:cNvGrpSpPr/>
         <p:nvPr/>
       </p:nvGrpSpPr>
@@ -3440,7 +3440,7 @@
       </p:grpSpPr>
       <p:sp>
         <p:nvSpPr>
-          <p:cNvPr id="186" name="Google Shape;186;p24"/>
+          <p:cNvPr id="197" name="Google Shape;197;p26"/>
           <p:cNvSpPr txBox="1"/>
           <p:nvPr>
             <p:ph type="title"/>
@@ -3449,7 +3449,7 @@
         <p:spPr>
           <a:xfrm>
             <a:off x="369989" y="554985"/>
-            <a:ext cx="11451715" cy="1179972"/>
+            <a:ext cx="11451714" cy="1179970"/>
           </a:xfrm>
           <a:prstGeom prst="rect">
             <a:avLst/>
@@ -3628,7 +3628,7 @@
       </p:sp>
       <p:sp>
         <p:nvSpPr>
-          <p:cNvPr id="187" name="Google Shape;187;p24"/>
+          <p:cNvPr id="198" name="Google Shape;198;p26"/>
           <p:cNvSpPr txBox="1"/>
           <p:nvPr>
             <p:ph idx="1" type="body"/>
@@ -3637,7 +3637,7 @@
         <p:spPr>
           <a:xfrm>
             <a:off x="6095847" y="3428914"/>
-            <a:ext cx="4779882" cy="1463965"/>
+            <a:ext cx="4779880" cy="1463963"/>
           </a:xfrm>
           <a:prstGeom prst="rect">
             <a:avLst/>
@@ -3819,7 +3819,7 @@
       </p:sp>
       <p:sp>
         <p:nvSpPr>
-          <p:cNvPr id="188" name="Google Shape;188;p24"/>
+          <p:cNvPr id="199" name="Google Shape;199;p26"/>
           <p:cNvSpPr txBox="1"/>
           <p:nvPr>
             <p:ph idx="2" type="body"/>
@@ -3828,7 +3828,7 @@
         <p:spPr>
           <a:xfrm>
             <a:off x="369989" y="3428902"/>
-            <a:ext cx="4779883" cy="1463965"/>
+            <a:ext cx="4779880" cy="1463963"/>
           </a:xfrm>
           <a:prstGeom prst="rect">
             <a:avLst/>
@@ -3975,7 +3975,7 @@
       </p:sp>
       <p:pic>
         <p:nvPicPr>
-          <p:cNvPr descr="Logo2.pngGoogle Shape;132;p11" id="189" name="Google Shape;189;p24"/>
+          <p:cNvPr descr="Logo2.pngGoogle Shape;132;p11" id="200" name="Google Shape;200;p26"/>
           <p:cNvPicPr preferRelativeResize="0"/>
           <p:nvPr/>
         </p:nvPicPr>
@@ -4002,7 +4002,7 @@
       </p:pic>
       <p:sp>
         <p:nvSpPr>
-          <p:cNvPr id="190" name="Google Shape;190;p24"/>
+          <p:cNvPr id="201" name="Google Shape;201;p26"/>
           <p:cNvSpPr txBox="1"/>
           <p:nvPr>
             <p:ph idx="12" type="sldNum"/>
@@ -4011,7 +4011,7 @@
         <p:spPr>
           <a:xfrm>
             <a:off x="11652438" y="6343529"/>
-            <a:ext cx="169330" cy="169330"/>
+            <a:ext cx="169196" cy="163996"/>
           </a:xfrm>
           <a:prstGeom prst="rect">
             <a:avLst/>
@@ -4299,7 +4299,7 @@
     </p:bg>
     <p:spTree>
       <p:nvGrpSpPr>
-        <p:cNvPr id="191" name="Shape 191"/>
+        <p:cNvPr id="202" name="Shape 202"/>
         <p:cNvGrpSpPr/>
         <p:nvPr/>
       </p:nvGrpSpPr>
@@ -4313,7 +4313,7 @@
       </p:grpSpPr>
       <p:sp>
         <p:nvSpPr>
-          <p:cNvPr id="192" name="Google Shape;192;p25"/>
+          <p:cNvPr id="203" name="Google Shape;203;p27"/>
           <p:cNvSpPr txBox="1"/>
           <p:nvPr>
             <p:ph type="title"/>
@@ -4322,7 +4322,7 @@
         <p:spPr>
           <a:xfrm>
             <a:off x="369989" y="554985"/>
-            <a:ext cx="4841082" cy="1179972"/>
+            <a:ext cx="4841079" cy="1179970"/>
           </a:xfrm>
           <a:prstGeom prst="rect">
             <a:avLst/>
@@ -4501,7 +4501,7 @@
       </p:sp>
       <p:sp>
         <p:nvSpPr>
-          <p:cNvPr id="193" name="Google Shape;193;p25"/>
+          <p:cNvPr id="204" name="Google Shape;204;p27"/>
           <p:cNvSpPr txBox="1"/>
           <p:nvPr>
             <p:ph idx="1" type="body"/>
@@ -4510,7 +4510,7 @@
         <p:spPr>
           <a:xfrm>
             <a:off x="6452739" y="1120571"/>
-            <a:ext cx="5011876" cy="992377"/>
+            <a:ext cx="5011875" cy="992375"/>
           </a:xfrm>
           <a:prstGeom prst="rect">
             <a:avLst/>
@@ -4712,7 +4712,7 @@
       </p:sp>
       <p:pic>
         <p:nvPicPr>
-          <p:cNvPr descr="Logo2.pngGoogle Shape;140;p12" id="194" name="Google Shape;194;p25"/>
+          <p:cNvPr descr="Logo2.pngGoogle Shape;140;p12" id="205" name="Google Shape;205;p27"/>
           <p:cNvPicPr preferRelativeResize="0"/>
           <p:nvPr/>
         </p:nvPicPr>
@@ -4739,7 +4739,7 @@
       </p:pic>
       <p:pic>
         <p:nvPicPr>
-          <p:cNvPr descr="check.pngGoogle Shape;141;p12" id="195" name="Google Shape;195;p25"/>
+          <p:cNvPr descr="check.pngGoogle Shape;141;p12" id="206" name="Google Shape;206;p27"/>
           <p:cNvPicPr preferRelativeResize="0"/>
           <p:nvPr/>
         </p:nvPicPr>
@@ -4766,7 +4766,7 @@
       </p:pic>
       <p:sp>
         <p:nvSpPr>
-          <p:cNvPr id="196" name="Google Shape;196;p25"/>
+          <p:cNvPr id="207" name="Google Shape;207;p27"/>
           <p:cNvSpPr txBox="1"/>
           <p:nvPr>
             <p:ph idx="2" type="body"/>
@@ -4775,7 +4775,7 @@
         <p:spPr>
           <a:xfrm>
             <a:off x="6452739" y="2461070"/>
-            <a:ext cx="5011876" cy="992377"/>
+            <a:ext cx="5011875" cy="992375"/>
           </a:xfrm>
           <a:prstGeom prst="rect">
             <a:avLst/>
@@ -4922,7 +4922,7 @@
       </p:sp>
       <p:pic>
         <p:nvPicPr>
-          <p:cNvPr descr="check.pngGoogle Shape;144;p12" id="197" name="Google Shape;197;p25"/>
+          <p:cNvPr descr="check.pngGoogle Shape;144;p12" id="208" name="Google Shape;208;p27"/>
           <p:cNvPicPr preferRelativeResize="0"/>
           <p:nvPr/>
         </p:nvPicPr>
@@ -4949,7 +4949,7 @@
       </p:pic>
       <p:sp>
         <p:nvSpPr>
-          <p:cNvPr id="198" name="Google Shape;198;p25"/>
+          <p:cNvPr id="209" name="Google Shape;209;p27"/>
           <p:cNvSpPr txBox="1"/>
           <p:nvPr>
             <p:ph idx="3" type="body"/>
@@ -4958,7 +4958,7 @@
         <p:spPr>
           <a:xfrm>
             <a:off x="6452739" y="3801570"/>
-            <a:ext cx="5011876" cy="992378"/>
+            <a:ext cx="5011875" cy="992375"/>
           </a:xfrm>
           <a:prstGeom prst="rect">
             <a:avLst/>
@@ -5105,7 +5105,7 @@
       </p:sp>
       <p:pic>
         <p:nvPicPr>
-          <p:cNvPr descr="check.pngGoogle Shape;147;p12" id="199" name="Google Shape;199;p25"/>
+          <p:cNvPr descr="check.pngGoogle Shape;147;p12" id="210" name="Google Shape;210;p27"/>
           <p:cNvPicPr preferRelativeResize="0"/>
           <p:nvPr/>
         </p:nvPicPr>
@@ -5132,7 +5132,7 @@
       </p:pic>
       <p:sp>
         <p:nvSpPr>
-          <p:cNvPr id="200" name="Google Shape;200;p25"/>
+          <p:cNvPr id="211" name="Google Shape;211;p27"/>
           <p:cNvSpPr txBox="1"/>
           <p:nvPr>
             <p:ph idx="4" type="body"/>
@@ -5141,7 +5141,7 @@
         <p:spPr>
           <a:xfrm>
             <a:off x="6452739" y="5153004"/>
-            <a:ext cx="5011876" cy="992377"/>
+            <a:ext cx="5011875" cy="992375"/>
           </a:xfrm>
           <a:prstGeom prst="rect">
             <a:avLst/>
@@ -5288,7 +5288,7 @@
       </p:sp>
       <p:pic>
         <p:nvPicPr>
-          <p:cNvPr descr="check.pngGoogle Shape;150;p12" id="201" name="Google Shape;201;p25"/>
+          <p:cNvPr descr="check.pngGoogle Shape;150;p12" id="212" name="Google Shape;212;p27"/>
           <p:cNvPicPr preferRelativeResize="0"/>
           <p:nvPr/>
         </p:nvPicPr>
@@ -5315,14 +5315,14 @@
       </p:pic>
       <p:cxnSp>
         <p:nvCxnSpPr>
-          <p:cNvPr id="202" name="Google Shape;202;p25"/>
+          <p:cNvPr id="213" name="Google Shape;213;p27"/>
           <p:cNvCxnSpPr/>
           <p:nvPr/>
         </p:nvCxnSpPr>
         <p:spPr>
-          <a:xfrm flipH="1">
-            <a:off x="5703924" y="383190"/>
-            <a:ext cx="1" cy="6097849"/>
+          <a:xfrm>
+            <a:off x="5703925" y="383190"/>
+            <a:ext cx="0" cy="6097847"/>
           </a:xfrm>
           <a:prstGeom prst="straightConnector1">
             <a:avLst/>
@@ -5341,7 +5341,7 @@
       </p:cxnSp>
       <p:sp>
         <p:nvSpPr>
-          <p:cNvPr id="203" name="Google Shape;203;p25"/>
+          <p:cNvPr id="214" name="Google Shape;214;p27"/>
           <p:cNvSpPr txBox="1"/>
           <p:nvPr>
             <p:ph idx="5" type="body"/>
@@ -5350,7 +5350,7 @@
         <p:spPr>
           <a:xfrm>
             <a:off x="369989" y="1415785"/>
-            <a:ext cx="4571488" cy="2682336"/>
+            <a:ext cx="4571486" cy="2682333"/>
           </a:xfrm>
           <a:prstGeom prst="rect">
             <a:avLst/>
@@ -5497,7 +5497,7 @@
       </p:sp>
       <p:sp>
         <p:nvSpPr>
-          <p:cNvPr id="204" name="Google Shape;204;p25"/>
+          <p:cNvPr id="215" name="Google Shape;215;p27"/>
           <p:cNvSpPr txBox="1"/>
           <p:nvPr>
             <p:ph idx="12" type="sldNum"/>
@@ -5506,7 +5506,7 @@
         <p:spPr>
           <a:xfrm>
             <a:off x="11652438" y="6343529"/>
-            <a:ext cx="169330" cy="169330"/>
+            <a:ext cx="169196" cy="163996"/>
           </a:xfrm>
           <a:prstGeom prst="rect">
             <a:avLst/>
@@ -5787,7 +5787,7 @@
   <p:cSld name="CUSTOM_13">
     <p:spTree>
       <p:nvGrpSpPr>
-        <p:cNvPr id="205" name="Shape 205"/>
+        <p:cNvPr id="216" name="Shape 216"/>
         <p:cNvGrpSpPr/>
         <p:nvPr/>
       </p:nvGrpSpPr>
@@ -5801,14 +5801,14 @@
       </p:grpSpPr>
       <p:sp>
         <p:nvSpPr>
-          <p:cNvPr id="206" name="Google Shape;206;p26"/>
+          <p:cNvPr id="217" name="Google Shape;217;p28"/>
           <p:cNvSpPr txBox="1"/>
           <p:nvPr/>
         </p:nvSpPr>
         <p:spPr>
           <a:xfrm>
             <a:off x="369989" y="2579837"/>
-            <a:ext cx="1106775" cy="1530696"/>
+            <a:ext cx="1106772" cy="1539161"/>
           </a:xfrm>
           <a:prstGeom prst="rect">
             <a:avLst/>
@@ -5859,7 +5859,7 @@
       </p:sp>
       <p:sp>
         <p:nvSpPr>
-          <p:cNvPr id="207" name="Google Shape;207;p26"/>
+          <p:cNvPr id="218" name="Google Shape;218;p28"/>
           <p:cNvSpPr txBox="1"/>
           <p:nvPr>
             <p:ph type="title"/>
@@ -5868,7 +5868,7 @@
         <p:spPr>
           <a:xfrm>
             <a:off x="369989" y="554985"/>
-            <a:ext cx="11451715" cy="1179972"/>
+            <a:ext cx="11451714" cy="1179970"/>
           </a:xfrm>
           <a:prstGeom prst="rect">
             <a:avLst/>
@@ -6042,7 +6042,7 @@
       </p:sp>
       <p:sp>
         <p:nvSpPr>
-          <p:cNvPr id="208" name="Google Shape;208;p26"/>
+          <p:cNvPr id="219" name="Google Shape;219;p28"/>
           <p:cNvSpPr txBox="1"/>
           <p:nvPr>
             <p:ph idx="1" type="body"/>
@@ -6051,7 +6051,7 @@
         <p:spPr>
           <a:xfrm>
             <a:off x="726948" y="4963874"/>
-            <a:ext cx="4733882" cy="1422366"/>
+            <a:ext cx="4733882" cy="1422364"/>
           </a:xfrm>
           <a:prstGeom prst="rect">
             <a:avLst/>
@@ -6238,7 +6238,7 @@
       </p:sp>
       <p:sp>
         <p:nvSpPr>
-          <p:cNvPr id="209" name="Google Shape;209;p26"/>
+          <p:cNvPr id="220" name="Google Shape;220;p28"/>
           <p:cNvSpPr txBox="1"/>
           <p:nvPr>
             <p:ph idx="2" type="body"/>
@@ -6247,7 +6247,7 @@
         <p:spPr>
           <a:xfrm>
             <a:off x="726948" y="3087021"/>
-            <a:ext cx="4733883" cy="1463965"/>
+            <a:ext cx="4733882" cy="1463963"/>
           </a:xfrm>
           <a:prstGeom prst="rect">
             <a:avLst/>
@@ -6394,14 +6394,14 @@
       </p:sp>
       <p:sp>
         <p:nvSpPr>
-          <p:cNvPr id="210" name="Google Shape;210;p26"/>
+          <p:cNvPr id="221" name="Google Shape;221;p28"/>
           <p:cNvSpPr txBox="1"/>
           <p:nvPr/>
         </p:nvSpPr>
         <p:spPr>
           <a:xfrm>
             <a:off x="5745580" y="2579837"/>
-            <a:ext cx="1106774" cy="1530696"/>
+            <a:ext cx="1106772" cy="1539161"/>
           </a:xfrm>
           <a:prstGeom prst="rect">
             <a:avLst/>
@@ -6452,7 +6452,7 @@
       </p:sp>
       <p:sp>
         <p:nvSpPr>
-          <p:cNvPr id="211" name="Google Shape;211;p26"/>
+          <p:cNvPr id="222" name="Google Shape;222;p28"/>
           <p:cNvSpPr txBox="1"/>
           <p:nvPr>
             <p:ph idx="3" type="body"/>
@@ -6461,7 +6461,7 @@
         <p:spPr>
           <a:xfrm>
             <a:off x="6102537" y="3087021"/>
-            <a:ext cx="4733883" cy="1463965"/>
+            <a:ext cx="4733882" cy="1463963"/>
           </a:xfrm>
           <a:prstGeom prst="rect">
             <a:avLst/>
@@ -6608,7 +6608,7 @@
       </p:sp>
       <p:pic>
         <p:nvPicPr>
-          <p:cNvPr descr="Logo-white.pngGoogle Shape;164;p13" id="212" name="Google Shape;212;p26"/>
+          <p:cNvPr descr="Logo-white.pngGoogle Shape;164;p13" id="223" name="Google Shape;223;p28"/>
           <p:cNvPicPr preferRelativeResize="0"/>
           <p:nvPr/>
         </p:nvPicPr>
@@ -6635,7 +6635,7 @@
       </p:pic>
       <p:sp>
         <p:nvSpPr>
-          <p:cNvPr id="213" name="Google Shape;213;p26"/>
+          <p:cNvPr id="224" name="Google Shape;224;p28"/>
           <p:cNvSpPr txBox="1"/>
           <p:nvPr>
             <p:ph idx="12" type="sldNum"/>
@@ -6644,7 +6644,7 @@
         <p:spPr>
           <a:xfrm>
             <a:off x="11652438" y="6343529"/>
-            <a:ext cx="169330" cy="169330"/>
+            <a:ext cx="169196" cy="163996"/>
           </a:xfrm>
           <a:prstGeom prst="rect">
             <a:avLst/>
@@ -6925,7 +6925,7 @@
   <p:cSld name="CUSTOM_15">
     <p:spTree>
       <p:nvGrpSpPr>
-        <p:cNvPr id="214" name="Shape 214"/>
+        <p:cNvPr id="225" name="Shape 225"/>
         <p:cNvGrpSpPr/>
         <p:nvPr/>
       </p:nvGrpSpPr>
@@ -6939,7 +6939,7 @@
       </p:grpSpPr>
       <p:sp>
         <p:nvSpPr>
-          <p:cNvPr id="215" name="Google Shape;215;p27"/>
+          <p:cNvPr id="226" name="Google Shape;226;p29"/>
           <p:cNvSpPr txBox="1"/>
           <p:nvPr>
             <p:ph type="title"/>
@@ -6948,7 +6948,7 @@
         <p:spPr>
           <a:xfrm>
             <a:off x="7095722" y="674783"/>
-            <a:ext cx="4725883" cy="772382"/>
+            <a:ext cx="4725882" cy="772381"/>
           </a:xfrm>
           <a:prstGeom prst="rect">
             <a:avLst/>
@@ -7123,7 +7123,7 @@
       </p:sp>
       <p:sp>
         <p:nvSpPr>
-          <p:cNvPr id="216" name="Google Shape;216;p27"/>
+          <p:cNvPr id="227" name="Google Shape;227;p29"/>
           <p:cNvSpPr/>
           <p:nvPr>
             <p:ph idx="2" type="pic"/>
@@ -7145,7 +7145,7 @@
       </p:sp>
       <p:sp>
         <p:nvSpPr>
-          <p:cNvPr id="217" name="Google Shape;217;p27"/>
+          <p:cNvPr id="228" name="Google Shape;228;p29"/>
           <p:cNvSpPr txBox="1"/>
           <p:nvPr>
             <p:ph idx="1" type="body"/>
@@ -7154,7 +7154,7 @@
         <p:spPr>
           <a:xfrm>
             <a:off x="369989" y="371791"/>
-            <a:ext cx="5110275" cy="183197"/>
+            <a:ext cx="5110272" cy="183195"/>
           </a:xfrm>
           <a:prstGeom prst="rect">
             <a:avLst/>
@@ -7321,7 +7321,7 @@
       </p:sp>
       <p:pic>
         <p:nvPicPr>
-          <p:cNvPr descr="Logo-white.pngGoogle Shape;169;p14" id="218" name="Google Shape;218;p27"/>
+          <p:cNvPr descr="Logo-white.pngGoogle Shape;169;p14" id="229" name="Google Shape;229;p29"/>
           <p:cNvPicPr preferRelativeResize="0"/>
           <p:nvPr/>
         </p:nvPicPr>
@@ -7348,7 +7348,7 @@
       </p:pic>
       <p:sp>
         <p:nvSpPr>
-          <p:cNvPr id="219" name="Google Shape;219;p27"/>
+          <p:cNvPr id="230" name="Google Shape;230;p29"/>
           <p:cNvSpPr txBox="1"/>
           <p:nvPr>
             <p:ph idx="12" type="sldNum"/>
@@ -7357,7 +7357,7 @@
         <p:spPr>
           <a:xfrm>
             <a:off x="11652438" y="6343529"/>
-            <a:ext cx="169330" cy="169330"/>
+            <a:ext cx="169196" cy="163996"/>
           </a:xfrm>
           <a:prstGeom prst="rect">
             <a:avLst/>
@@ -7638,7 +7638,7 @@
   <p:cSld name="CUSTOM_17_1">
     <p:spTree>
       <p:nvGrpSpPr>
-        <p:cNvPr id="220" name="Shape 220"/>
+        <p:cNvPr id="231" name="Shape 231"/>
         <p:cNvGrpSpPr/>
         <p:nvPr/>
       </p:nvGrpSpPr>
@@ -7652,7 +7652,7 @@
       </p:grpSpPr>
       <p:sp>
         <p:nvSpPr>
-          <p:cNvPr id="221" name="Google Shape;221;p28"/>
+          <p:cNvPr id="232" name="Google Shape;232;p30"/>
           <p:cNvSpPr txBox="1"/>
           <p:nvPr>
             <p:ph idx="1" type="body"/>
@@ -7661,7 +7661,7 @@
         <p:spPr>
           <a:xfrm>
             <a:off x="369989" y="4432758"/>
-            <a:ext cx="2345543" cy="386792"/>
+            <a:ext cx="2345541" cy="386790"/>
           </a:xfrm>
           <a:prstGeom prst="rect">
             <a:avLst/>
@@ -7848,7 +7848,7 @@
       </p:sp>
       <p:sp>
         <p:nvSpPr>
-          <p:cNvPr id="222" name="Google Shape;222;p28"/>
+          <p:cNvPr id="233" name="Google Shape;233;p30"/>
           <p:cNvSpPr/>
           <p:nvPr>
             <p:ph idx="2" type="pic"/>
@@ -7857,7 +7857,7 @@
         <p:spPr>
           <a:xfrm>
             <a:off x="385456" y="1782329"/>
-            <a:ext cx="2334744" cy="2363940"/>
+            <a:ext cx="2334742" cy="2363941"/>
           </a:xfrm>
           <a:prstGeom prst="rect">
             <a:avLst/>
@@ -7870,7 +7870,7 @@
       </p:sp>
       <p:sp>
         <p:nvSpPr>
-          <p:cNvPr id="223" name="Google Shape;223;p28"/>
+          <p:cNvPr id="234" name="Google Shape;234;p30"/>
           <p:cNvSpPr/>
           <p:nvPr>
             <p:ph idx="3" type="pic"/>
@@ -7879,7 +7879,7 @@
         <p:spPr>
           <a:xfrm>
             <a:off x="2890178" y="1782329"/>
-            <a:ext cx="2334743" cy="2363940"/>
+            <a:ext cx="2334742" cy="2363941"/>
           </a:xfrm>
           <a:prstGeom prst="rect">
             <a:avLst/>
@@ -7892,7 +7892,7 @@
       </p:sp>
       <p:sp>
         <p:nvSpPr>
-          <p:cNvPr id="224" name="Google Shape;224;p28"/>
+          <p:cNvPr id="235" name="Google Shape;235;p30"/>
           <p:cNvSpPr/>
           <p:nvPr>
             <p:ph idx="4" type="pic"/>
@@ -7901,7 +7901,7 @@
         <p:spPr>
           <a:xfrm>
             <a:off x="5394898" y="1782329"/>
-            <a:ext cx="2334743" cy="2363940"/>
+            <a:ext cx="2334742" cy="2363941"/>
           </a:xfrm>
           <a:prstGeom prst="rect">
             <a:avLst/>
@@ -7914,7 +7914,7 @@
       </p:sp>
       <p:sp>
         <p:nvSpPr>
-          <p:cNvPr id="225" name="Google Shape;225;p28"/>
+          <p:cNvPr id="236" name="Google Shape;236;p30"/>
           <p:cNvSpPr/>
           <p:nvPr>
             <p:ph idx="5" type="pic"/>
@@ -7923,7 +7923,7 @@
         <p:spPr>
           <a:xfrm>
             <a:off x="7883420" y="1782329"/>
-            <a:ext cx="2334743" cy="2363940"/>
+            <a:ext cx="2334742" cy="2363941"/>
           </a:xfrm>
           <a:prstGeom prst="rect">
             <a:avLst/>
@@ -7936,7 +7936,7 @@
       </p:sp>
       <p:sp>
         <p:nvSpPr>
-          <p:cNvPr id="226" name="Google Shape;226;p28"/>
+          <p:cNvPr id="237" name="Google Shape;237;p30"/>
           <p:cNvSpPr txBox="1"/>
           <p:nvPr>
             <p:ph idx="6" type="body"/>
@@ -7945,7 +7945,7 @@
         <p:spPr>
           <a:xfrm>
             <a:off x="369989" y="4880001"/>
-            <a:ext cx="2345543" cy="664785"/>
+            <a:ext cx="2345541" cy="664783"/>
           </a:xfrm>
           <a:prstGeom prst="rect">
             <a:avLst/>
@@ -8092,7 +8092,7 @@
       </p:sp>
       <p:sp>
         <p:nvSpPr>
-          <p:cNvPr id="227" name="Google Shape;227;p28"/>
+          <p:cNvPr id="238" name="Google Shape;238;p30"/>
           <p:cNvSpPr txBox="1"/>
           <p:nvPr>
             <p:ph idx="7" type="body"/>
@@ -8101,7 +8101,7 @@
         <p:spPr>
           <a:xfrm>
             <a:off x="2884778" y="4880001"/>
-            <a:ext cx="2345543" cy="664785"/>
+            <a:ext cx="2345541" cy="664783"/>
           </a:xfrm>
           <a:prstGeom prst="rect">
             <a:avLst/>
@@ -8248,7 +8248,7 @@
       </p:sp>
       <p:sp>
         <p:nvSpPr>
-          <p:cNvPr id="228" name="Google Shape;228;p28"/>
+          <p:cNvPr id="239" name="Google Shape;239;p30"/>
           <p:cNvSpPr txBox="1"/>
           <p:nvPr>
             <p:ph idx="8" type="body"/>
@@ -8257,7 +8257,7 @@
         <p:spPr>
           <a:xfrm>
             <a:off x="5399566" y="4880001"/>
-            <a:ext cx="2345543" cy="664785"/>
+            <a:ext cx="2345541" cy="664783"/>
           </a:xfrm>
           <a:prstGeom prst="rect">
             <a:avLst/>
@@ -8404,7 +8404,7 @@
       </p:sp>
       <p:sp>
         <p:nvSpPr>
-          <p:cNvPr id="229" name="Google Shape;229;p28"/>
+          <p:cNvPr id="240" name="Google Shape;240;p30"/>
           <p:cNvSpPr txBox="1"/>
           <p:nvPr>
             <p:ph idx="9" type="body"/>
@@ -8413,7 +8413,7 @@
         <p:spPr>
           <a:xfrm>
             <a:off x="7866621" y="4880001"/>
-            <a:ext cx="2345543" cy="664785"/>
+            <a:ext cx="2345541" cy="664783"/>
           </a:xfrm>
           <a:prstGeom prst="rect">
             <a:avLst/>
@@ -8560,7 +8560,7 @@
       </p:sp>
       <p:sp>
         <p:nvSpPr>
-          <p:cNvPr id="230" name="Google Shape;230;p28"/>
+          <p:cNvPr id="241" name="Google Shape;241;p30"/>
           <p:cNvSpPr txBox="1"/>
           <p:nvPr>
             <p:ph type="title"/>
@@ -8569,7 +8569,7 @@
         <p:spPr>
           <a:xfrm>
             <a:off x="369989" y="554985"/>
-            <a:ext cx="11451715" cy="1179972"/>
+            <a:ext cx="11451714" cy="1179970"/>
           </a:xfrm>
           <a:prstGeom prst="rect">
             <a:avLst/>
@@ -8743,7 +8743,7 @@
       </p:sp>
       <p:pic>
         <p:nvPicPr>
-          <p:cNvPr descr="Logo-white.pngGoogle Shape;187;p15" id="231" name="Google Shape;231;p28"/>
+          <p:cNvPr descr="Logo-white.pngGoogle Shape;187;p15" id="242" name="Google Shape;242;p30"/>
           <p:cNvPicPr preferRelativeResize="0"/>
           <p:nvPr/>
         </p:nvPicPr>
@@ -8770,7 +8770,7 @@
       </p:pic>
       <p:sp>
         <p:nvSpPr>
-          <p:cNvPr id="232" name="Google Shape;232;p28"/>
+          <p:cNvPr id="243" name="Google Shape;243;p30"/>
           <p:cNvSpPr txBox="1"/>
           <p:nvPr>
             <p:ph idx="12" type="sldNum"/>
@@ -8779,7 +8779,7 @@
         <p:spPr>
           <a:xfrm>
             <a:off x="11652438" y="6343529"/>
-            <a:ext cx="169330" cy="169330"/>
+            <a:ext cx="169196" cy="163996"/>
           </a:xfrm>
           <a:prstGeom prst="rect">
             <a:avLst/>
@@ -9230,7 +9230,7 @@
   <p:cSld name="Title and image">
     <p:spTree>
       <p:nvGrpSpPr>
-        <p:cNvPr id="233" name="Shape 233"/>
+        <p:cNvPr id="244" name="Shape 244"/>
         <p:cNvGrpSpPr/>
         <p:nvPr/>
       </p:nvGrpSpPr>
@@ -9244,7 +9244,7 @@
       </p:grpSpPr>
       <p:sp>
         <p:nvSpPr>
-          <p:cNvPr id="234" name="Google Shape;234;p29"/>
+          <p:cNvPr id="245" name="Google Shape;245;p31"/>
           <p:cNvSpPr/>
           <p:nvPr>
             <p:ph idx="2" type="pic"/>
@@ -9253,7 +9253,7 @@
         <p:spPr>
           <a:xfrm>
             <a:off x="369989" y="1560526"/>
-            <a:ext cx="11451715" cy="4919478"/>
+            <a:ext cx="11451714" cy="4919477"/>
           </a:xfrm>
           <a:prstGeom prst="rect">
             <a:avLst/>
@@ -9266,7 +9266,7 @@
       </p:sp>
       <p:sp>
         <p:nvSpPr>
-          <p:cNvPr id="235" name="Google Shape;235;p29"/>
+          <p:cNvPr id="246" name="Google Shape;246;p31"/>
           <p:cNvSpPr txBox="1"/>
           <p:nvPr>
             <p:ph type="title"/>
@@ -9275,7 +9275,7 @@
         <p:spPr>
           <a:xfrm>
             <a:off x="726948" y="369989"/>
-            <a:ext cx="10737731" cy="795981"/>
+            <a:ext cx="10737731" cy="795980"/>
           </a:xfrm>
           <a:prstGeom prst="rect">
             <a:avLst/>
@@ -9449,7 +9449,7 @@
       </p:sp>
       <p:sp>
         <p:nvSpPr>
-          <p:cNvPr id="236" name="Google Shape;236;p29"/>
+          <p:cNvPr id="247" name="Google Shape;247;p31"/>
           <p:cNvSpPr txBox="1"/>
           <p:nvPr>
             <p:ph idx="12" type="sldNum"/>
@@ -9458,7 +9458,7 @@
         <p:spPr>
           <a:xfrm>
             <a:off x="5892653" y="6169928"/>
-            <a:ext cx="2844729" cy="372525"/>
+            <a:ext cx="2844729" cy="369191"/>
           </a:xfrm>
           <a:prstGeom prst="rect">
             <a:avLst/>
@@ -9710,7 +9710,7 @@
     </p:bg>
     <p:spTree>
       <p:nvGrpSpPr>
-        <p:cNvPr id="237" name="Shape 237"/>
+        <p:cNvPr id="248" name="Shape 248"/>
         <p:cNvGrpSpPr/>
         <p:nvPr/>
       </p:nvGrpSpPr>
@@ -9724,14 +9724,14 @@
       </p:grpSpPr>
       <p:sp>
         <p:nvSpPr>
-          <p:cNvPr id="238" name="Google Shape;238;p30"/>
+          <p:cNvPr id="249" name="Google Shape;249;p32"/>
           <p:cNvSpPr/>
           <p:nvPr/>
         </p:nvSpPr>
         <p:spPr>
           <a:xfrm>
             <a:off x="218060" y="205262"/>
-            <a:ext cx="11737708" cy="6426639"/>
+            <a:ext cx="11737706" cy="6426639"/>
           </a:xfrm>
           <a:prstGeom prst="roundRect">
             <a:avLst>
@@ -9785,7 +9785,7 @@
       </p:sp>
       <p:sp>
         <p:nvSpPr>
-          <p:cNvPr id="239" name="Google Shape;239;p30"/>
+          <p:cNvPr id="250" name="Google Shape;250;p32"/>
           <p:cNvSpPr txBox="1"/>
           <p:nvPr>
             <p:ph type="title"/>
@@ -9794,7 +9794,7 @@
         <p:spPr>
           <a:xfrm>
             <a:off x="609585" y="544516"/>
-            <a:ext cx="10855328" cy="692384"/>
+            <a:ext cx="10855328" cy="692383"/>
           </a:xfrm>
           <a:prstGeom prst="rect">
             <a:avLst/>
@@ -9973,14 +9973,14 @@
       </p:sp>
       <p:sp>
         <p:nvSpPr>
-          <p:cNvPr id="240" name="Google Shape;240;p30"/>
+          <p:cNvPr id="251" name="Google Shape;251;p32"/>
           <p:cNvSpPr/>
           <p:nvPr/>
         </p:nvSpPr>
         <p:spPr>
           <a:xfrm>
             <a:off x="10110579" y="6325275"/>
-            <a:ext cx="2081149" cy="532788"/>
+            <a:ext cx="2081148" cy="532787"/>
           </a:xfrm>
           <a:prstGeom prst="roundRect">
             <a:avLst>
@@ -10034,7 +10034,7 @@
       </p:sp>
       <p:sp>
         <p:nvSpPr>
-          <p:cNvPr id="241" name="Google Shape;241;p30"/>
+          <p:cNvPr id="252" name="Google Shape;252;p32"/>
           <p:cNvSpPr txBox="1"/>
           <p:nvPr>
             <p:ph idx="1" type="body"/>
@@ -10043,7 +10043,7 @@
         <p:spPr>
           <a:xfrm>
             <a:off x="609585" y="1237034"/>
-            <a:ext cx="5110273" cy="255995"/>
+            <a:ext cx="5110272" cy="255994"/>
           </a:xfrm>
           <a:prstGeom prst="rect">
             <a:avLst/>
@@ -10250,7 +10250,7 @@
       </p:sp>
       <p:pic>
         <p:nvPicPr>
-          <p:cNvPr descr="Logo-white.pngGoogle Shape;197;p17" id="242" name="Google Shape;242;p30"/>
+          <p:cNvPr descr="Logo-white.pngGoogle Shape;197;p17" id="253" name="Google Shape;253;p32"/>
           <p:cNvPicPr preferRelativeResize="0"/>
           <p:nvPr/>
         </p:nvPicPr>
@@ -10258,7 +10258,7 @@
           <a:blip r:embed="rId2">
             <a:alphaModFix/>
           </a:blip>
-          <a:srcRect b="0" l="17014" r="0" t="0"/>
+          <a:srcRect b="0" l="17012" r="0" t="0"/>
           <a:stretch/>
         </p:blipFill>
         <p:spPr>
@@ -10277,7 +10277,7 @@
       </p:pic>
       <p:sp>
         <p:nvSpPr>
-          <p:cNvPr id="243" name="Google Shape;243;p30"/>
+          <p:cNvPr id="254" name="Google Shape;254;p32"/>
           <p:cNvSpPr txBox="1"/>
           <p:nvPr>
             <p:ph idx="2" type="body"/>
@@ -10433,7 +10433,7 @@
       </p:sp>
       <p:sp>
         <p:nvSpPr>
-          <p:cNvPr id="244" name="Google Shape;244;p30"/>
+          <p:cNvPr id="255" name="Google Shape;255;p32"/>
           <p:cNvSpPr txBox="1"/>
           <p:nvPr>
             <p:ph idx="12" type="sldNum"/>
@@ -10442,7 +10442,7 @@
         <p:spPr>
           <a:xfrm>
             <a:off x="11767890" y="6471821"/>
-            <a:ext cx="169330" cy="169330"/>
+            <a:ext cx="169196" cy="163996"/>
           </a:xfrm>
           <a:prstGeom prst="rect">
             <a:avLst/>
@@ -10730,7 +10730,7 @@
     </p:bg>
     <p:spTree>
       <p:nvGrpSpPr>
-        <p:cNvPr id="245" name="Shape 245"/>
+        <p:cNvPr id="256" name="Shape 256"/>
         <p:cNvGrpSpPr/>
         <p:nvPr/>
       </p:nvGrpSpPr>
@@ -10744,14 +10744,14 @@
       </p:grpSpPr>
       <p:sp>
         <p:nvSpPr>
-          <p:cNvPr id="246" name="Google Shape;246;p31"/>
+          <p:cNvPr id="257" name="Google Shape;257;p33"/>
           <p:cNvSpPr/>
           <p:nvPr/>
         </p:nvSpPr>
         <p:spPr>
           <a:xfrm>
             <a:off x="218061" y="205262"/>
-            <a:ext cx="11737708" cy="6426641"/>
+            <a:ext cx="11737706" cy="6426639"/>
           </a:xfrm>
           <a:prstGeom prst="roundRect">
             <a:avLst>
@@ -10805,7 +10805,7 @@
       </p:sp>
       <p:sp>
         <p:nvSpPr>
-          <p:cNvPr id="247" name="Google Shape;247;p31"/>
+          <p:cNvPr id="258" name="Google Shape;258;p33"/>
           <p:cNvSpPr txBox="1"/>
           <p:nvPr>
             <p:ph type="title"/>
@@ -10814,7 +10814,7 @@
         <p:spPr>
           <a:xfrm>
             <a:off x="609585" y="544514"/>
-            <a:ext cx="10855328" cy="692384"/>
+            <a:ext cx="10855328" cy="692383"/>
           </a:xfrm>
           <a:prstGeom prst="rect">
             <a:avLst/>
@@ -10993,14 +10993,14 @@
       </p:sp>
       <p:sp>
         <p:nvSpPr>
-          <p:cNvPr id="248" name="Google Shape;248;p31"/>
+          <p:cNvPr id="259" name="Google Shape;259;p33"/>
           <p:cNvSpPr/>
           <p:nvPr/>
         </p:nvSpPr>
         <p:spPr>
           <a:xfrm>
             <a:off x="10110579" y="6325274"/>
-            <a:ext cx="2081149" cy="532788"/>
+            <a:ext cx="2081148" cy="532787"/>
           </a:xfrm>
           <a:prstGeom prst="roundRect">
             <a:avLst>
@@ -11054,7 +11054,7 @@
       </p:sp>
       <p:sp>
         <p:nvSpPr>
-          <p:cNvPr id="249" name="Google Shape;249;p31"/>
+          <p:cNvPr id="260" name="Google Shape;260;p33"/>
           <p:cNvSpPr txBox="1"/>
           <p:nvPr>
             <p:ph idx="1" type="body"/>
@@ -11063,7 +11063,7 @@
         <p:spPr>
           <a:xfrm>
             <a:off x="609585" y="1237036"/>
-            <a:ext cx="5110273" cy="255995"/>
+            <a:ext cx="5110272" cy="255994"/>
           </a:xfrm>
           <a:prstGeom prst="rect">
             <a:avLst/>
@@ -11270,7 +11270,7 @@
       </p:sp>
       <p:pic>
         <p:nvPicPr>
-          <p:cNvPr descr="Logo-white.pngGoogle Shape;197;p17" id="250" name="Google Shape;250;p31"/>
+          <p:cNvPr descr="Logo-white.pngGoogle Shape;197;p17" id="261" name="Google Shape;261;p33"/>
           <p:cNvPicPr preferRelativeResize="0"/>
           <p:nvPr/>
         </p:nvPicPr>
@@ -11278,7 +11278,7 @@
           <a:blip r:embed="rId2">
             <a:alphaModFix/>
           </a:blip>
-          <a:srcRect b="0" l="17013" r="0" t="0"/>
+          <a:srcRect b="0" l="17012" r="0" t="0"/>
           <a:stretch/>
         </p:blipFill>
         <p:spPr>
@@ -11297,7 +11297,7 @@
       </p:pic>
       <p:sp>
         <p:nvSpPr>
-          <p:cNvPr id="251" name="Google Shape;251;p31"/>
+          <p:cNvPr id="262" name="Google Shape;262;p33"/>
           <p:cNvSpPr txBox="1"/>
           <p:nvPr>
             <p:ph idx="2" type="body"/>
@@ -11306,7 +11306,7 @@
         <p:spPr>
           <a:xfrm>
             <a:off x="609585" y="2203012"/>
-            <a:ext cx="5486663" cy="2630736"/>
+            <a:ext cx="5486663" cy="2630734"/>
           </a:xfrm>
           <a:prstGeom prst="rect">
             <a:avLst/>
@@ -11453,7 +11453,7 @@
       </p:sp>
       <p:sp>
         <p:nvSpPr>
-          <p:cNvPr id="252" name="Google Shape;252;p31"/>
+          <p:cNvPr id="263" name="Google Shape;263;p33"/>
           <p:cNvSpPr txBox="1"/>
           <p:nvPr>
             <p:ph idx="12" type="sldNum"/>
@@ -11462,7 +11462,7 @@
         <p:spPr>
           <a:xfrm>
             <a:off x="11767890" y="6471821"/>
-            <a:ext cx="169330" cy="169330"/>
+            <a:ext cx="169196" cy="143596"/>
           </a:xfrm>
           <a:prstGeom prst="rect">
             <a:avLst/>
@@ -11477,7 +11477,7 @@
             <a:spAutoFit/>
           </a:bodyPr>
           <a:lstStyle>
-            <a:lvl1pPr indent="-50798" lvl="0" marL="50798" algn="r">
+            <a:lvl1pPr indent="-50797" lvl="0" marL="50797" algn="r">
               <a:lnSpc>
                 <a:spcPct val="100000"/>
               </a:lnSpc>
@@ -11503,7 +11503,7 @@
                 <a:sym typeface="Montserrat"/>
               </a:defRPr>
             </a:lvl1pPr>
-            <a:lvl2pPr indent="-50798" lvl="1" marL="50798" algn="r">
+            <a:lvl2pPr indent="-50797" lvl="1" marL="50797" algn="r">
               <a:lnSpc>
                 <a:spcPct val="100000"/>
               </a:lnSpc>
@@ -11529,7 +11529,7 @@
                 <a:sym typeface="Montserrat"/>
               </a:defRPr>
             </a:lvl2pPr>
-            <a:lvl3pPr indent="-50798" lvl="2" marL="50798" algn="r">
+            <a:lvl3pPr indent="-50797" lvl="2" marL="50797" algn="r">
               <a:lnSpc>
                 <a:spcPct val="100000"/>
               </a:lnSpc>
@@ -11555,7 +11555,7 @@
                 <a:sym typeface="Montserrat"/>
               </a:defRPr>
             </a:lvl3pPr>
-            <a:lvl4pPr indent="-50798" lvl="3" marL="50798" algn="r">
+            <a:lvl4pPr indent="-50797" lvl="3" marL="50797" algn="r">
               <a:lnSpc>
                 <a:spcPct val="100000"/>
               </a:lnSpc>
@@ -11581,7 +11581,7 @@
                 <a:sym typeface="Montserrat"/>
               </a:defRPr>
             </a:lvl4pPr>
-            <a:lvl5pPr indent="-50798" lvl="4" marL="50798" algn="r">
+            <a:lvl5pPr indent="-50797" lvl="4" marL="50797" algn="r">
               <a:lnSpc>
                 <a:spcPct val="100000"/>
               </a:lnSpc>
@@ -11607,7 +11607,7 @@
                 <a:sym typeface="Montserrat"/>
               </a:defRPr>
             </a:lvl5pPr>
-            <a:lvl6pPr indent="-50798" lvl="5" marL="50798" algn="r">
+            <a:lvl6pPr indent="-50797" lvl="5" marL="50797" algn="r">
               <a:lnSpc>
                 <a:spcPct val="100000"/>
               </a:lnSpc>
@@ -11633,7 +11633,7 @@
                 <a:sym typeface="Montserrat"/>
               </a:defRPr>
             </a:lvl6pPr>
-            <a:lvl7pPr indent="-50798" lvl="6" marL="50798" algn="r">
+            <a:lvl7pPr indent="-50797" lvl="6" marL="50797" algn="r">
               <a:lnSpc>
                 <a:spcPct val="100000"/>
               </a:lnSpc>
@@ -11659,7 +11659,7 @@
                 <a:sym typeface="Montserrat"/>
               </a:defRPr>
             </a:lvl7pPr>
-            <a:lvl8pPr indent="-50798" lvl="7" marL="50798" algn="r">
+            <a:lvl8pPr indent="-50797" lvl="7" marL="50797" algn="r">
               <a:lnSpc>
                 <a:spcPct val="100000"/>
               </a:lnSpc>
@@ -11685,7 +11685,7 @@
                 <a:sym typeface="Montserrat"/>
               </a:defRPr>
             </a:lvl8pPr>
-            <a:lvl9pPr indent="-50798" lvl="8" marL="50798" algn="r">
+            <a:lvl9pPr indent="-50797" lvl="8" marL="50797" algn="r">
               <a:lnSpc>
                 <a:spcPct val="100000"/>
               </a:lnSpc>
@@ -11713,7 +11713,7 @@
             </a:lvl9pPr>
           </a:lstStyle>
           <a:p>
-            <a:pPr indent="-50798" lvl="0" marL="50798" rtl="0" algn="r">
+            <a:pPr indent="-50797" lvl="0" marL="50797" rtl="0" algn="r">
               <a:spcBef>
                 <a:spcPts val="0"/>
               </a:spcBef>
@@ -11750,7 +11750,7 @@
     </p:bg>
     <p:spTree>
       <p:nvGrpSpPr>
-        <p:cNvPr id="253" name="Shape 253"/>
+        <p:cNvPr id="264" name="Shape 264"/>
         <p:cNvGrpSpPr/>
         <p:nvPr/>
       </p:nvGrpSpPr>
@@ -11764,7 +11764,7 @@
       </p:grpSpPr>
       <p:sp>
         <p:nvSpPr>
-          <p:cNvPr id="254" name="Google Shape;254;p32"/>
+          <p:cNvPr id="265" name="Google Shape;265;p34"/>
           <p:cNvSpPr txBox="1"/>
           <p:nvPr>
             <p:ph idx="12" type="sldNum"/>
@@ -11773,7 +11773,7 @@
         <p:spPr>
           <a:xfrm>
             <a:off x="11673899" y="6332976"/>
-            <a:ext cx="466443" cy="453909"/>
+            <a:ext cx="466388" cy="471988"/>
           </a:xfrm>
           <a:prstGeom prst="rect">
             <a:avLst/>
@@ -12030,7 +12030,7 @@
     </p:bg>
     <p:spTree>
       <p:nvGrpSpPr>
-        <p:cNvPr id="84" name="Shape 84"/>
+        <p:cNvPr id="95" name="Shape 95"/>
         <p:cNvGrpSpPr/>
         <p:nvPr/>
       </p:nvGrpSpPr>
@@ -12044,14 +12044,14 @@
       </p:grpSpPr>
       <p:sp>
         <p:nvSpPr>
-          <p:cNvPr id="85" name="Google Shape;85;p16"/>
+          <p:cNvPr id="96" name="Google Shape;96;p18"/>
           <p:cNvSpPr/>
           <p:nvPr/>
         </p:nvSpPr>
         <p:spPr>
           <a:xfrm>
             <a:off x="375889" y="368323"/>
-            <a:ext cx="11451715" cy="6131848"/>
+            <a:ext cx="11451714" cy="6131847"/>
           </a:xfrm>
           <a:prstGeom prst="roundRect">
             <a:avLst>
@@ -12113,7 +12113,7 @@
       </p:sp>
       <p:sp>
         <p:nvSpPr>
-          <p:cNvPr id="86" name="Google Shape;86;p16"/>
+          <p:cNvPr id="97" name="Google Shape;97;p18"/>
           <p:cNvSpPr txBox="1"/>
           <p:nvPr>
             <p:ph type="title"/>
@@ -12122,7 +12122,7 @@
         <p:spPr>
           <a:xfrm>
             <a:off x="3464545" y="4657317"/>
-            <a:ext cx="7980203" cy="1326368"/>
+            <a:ext cx="7980200" cy="1326367"/>
           </a:xfrm>
           <a:prstGeom prst="rect">
             <a:avLst/>
@@ -12297,7 +12297,7 @@
       </p:sp>
       <p:sp>
         <p:nvSpPr>
-          <p:cNvPr id="87" name="Google Shape;87;p16"/>
+          <p:cNvPr id="98" name="Google Shape;98;p18"/>
           <p:cNvSpPr txBox="1"/>
           <p:nvPr>
             <p:ph idx="12" type="sldNum"/>
@@ -12306,7 +12306,7 @@
         <p:spPr>
           <a:xfrm>
             <a:off x="5892653" y="6169928"/>
-            <a:ext cx="2844729" cy="372525"/>
+            <a:ext cx="2844729" cy="369191"/>
           </a:xfrm>
           <a:prstGeom prst="rect">
             <a:avLst/>
@@ -12558,7 +12558,7 @@
     </p:bg>
     <p:spTree>
       <p:nvGrpSpPr>
-        <p:cNvPr id="88" name="Shape 88"/>
+        <p:cNvPr id="99" name="Shape 99"/>
         <p:cNvGrpSpPr/>
         <p:nvPr/>
       </p:nvGrpSpPr>
@@ -12572,7 +12572,7 @@
       </p:grpSpPr>
       <p:sp>
         <p:nvSpPr>
-          <p:cNvPr id="89" name="Google Shape;89;p17"/>
+          <p:cNvPr id="100" name="Google Shape;100;p19"/>
           <p:cNvSpPr txBox="1"/>
           <p:nvPr>
             <p:ph idx="1" type="body"/>
@@ -12581,7 +12581,7 @@
         <p:spPr>
           <a:xfrm>
             <a:off x="557234" y="3550890"/>
-            <a:ext cx="1783155" cy="521188"/>
+            <a:ext cx="1783155" cy="521187"/>
           </a:xfrm>
           <a:prstGeom prst="rect">
             <a:avLst/>
@@ -12788,7 +12788,7 @@
       </p:sp>
       <p:sp>
         <p:nvSpPr>
-          <p:cNvPr id="90" name="Google Shape;90;p17"/>
+          <p:cNvPr id="101" name="Google Shape;101;p19"/>
           <p:cNvSpPr txBox="1"/>
           <p:nvPr>
             <p:ph idx="2" type="body"/>
@@ -12797,7 +12797,7 @@
         <p:spPr>
           <a:xfrm>
             <a:off x="557067" y="4250340"/>
-            <a:ext cx="1783155" cy="1569162"/>
+            <a:ext cx="1783155" cy="1569161"/>
           </a:xfrm>
           <a:prstGeom prst="rect">
             <a:avLst/>
@@ -12944,7 +12944,7 @@
       </p:sp>
       <p:sp>
         <p:nvSpPr>
-          <p:cNvPr id="91" name="Google Shape;91;p17"/>
+          <p:cNvPr id="102" name="Google Shape;102;p19"/>
           <p:cNvSpPr txBox="1"/>
           <p:nvPr>
             <p:ph idx="3" type="body"/>
@@ -12953,7 +12953,7 @@
         <p:spPr>
           <a:xfrm>
             <a:off x="2889694" y="4250340"/>
-            <a:ext cx="1783155" cy="1569162"/>
+            <a:ext cx="1783155" cy="1569161"/>
           </a:xfrm>
           <a:prstGeom prst="rect">
             <a:avLst/>
@@ -13100,7 +13100,7 @@
       </p:sp>
       <p:sp>
         <p:nvSpPr>
-          <p:cNvPr id="92" name="Google Shape;92;p17"/>
+          <p:cNvPr id="103" name="Google Shape;103;p19"/>
           <p:cNvSpPr txBox="1"/>
           <p:nvPr>
             <p:ph idx="4" type="body"/>
@@ -13109,7 +13109,7 @@
         <p:spPr>
           <a:xfrm>
             <a:off x="5204270" y="4250340"/>
-            <a:ext cx="1783155" cy="1569162"/>
+            <a:ext cx="1783155" cy="1569161"/>
           </a:xfrm>
           <a:prstGeom prst="rect">
             <a:avLst/>
@@ -13256,7 +13256,7 @@
       </p:sp>
       <p:sp>
         <p:nvSpPr>
-          <p:cNvPr id="93" name="Google Shape;93;p17"/>
+          <p:cNvPr id="104" name="Google Shape;104;p19"/>
           <p:cNvSpPr txBox="1"/>
           <p:nvPr>
             <p:ph idx="5" type="body"/>
@@ -13265,7 +13265,7 @@
         <p:spPr>
           <a:xfrm>
             <a:off x="7531310" y="4250340"/>
-            <a:ext cx="1783157" cy="1569162"/>
+            <a:ext cx="1783155" cy="1569161"/>
           </a:xfrm>
           <a:prstGeom prst="rect">
             <a:avLst/>
@@ -13412,7 +13412,7 @@
       </p:sp>
       <p:sp>
         <p:nvSpPr>
-          <p:cNvPr id="94" name="Google Shape;94;p17"/>
+          <p:cNvPr id="105" name="Google Shape;105;p19"/>
           <p:cNvSpPr txBox="1"/>
           <p:nvPr>
             <p:ph idx="6" type="body"/>
@@ -13421,7 +13421,7 @@
         <p:spPr>
           <a:xfrm>
             <a:off x="9846808" y="4250340"/>
-            <a:ext cx="1783155" cy="1569162"/>
+            <a:ext cx="1783155" cy="1569161"/>
           </a:xfrm>
           <a:prstGeom prst="rect">
             <a:avLst/>
@@ -13568,7 +13568,7 @@
       </p:sp>
       <p:sp>
         <p:nvSpPr>
-          <p:cNvPr id="95" name="Google Shape;95;p17"/>
+          <p:cNvPr id="106" name="Google Shape;106;p19"/>
           <p:cNvSpPr txBox="1"/>
           <p:nvPr>
             <p:ph type="title"/>
@@ -13577,7 +13577,7 @@
         <p:spPr>
           <a:xfrm>
             <a:off x="369989" y="554985"/>
-            <a:ext cx="11451715" cy="1179972"/>
+            <a:ext cx="11451714" cy="1179970"/>
           </a:xfrm>
           <a:prstGeom prst="rect">
             <a:avLst/>
@@ -13756,7 +13756,7 @@
       </p:sp>
       <p:pic>
         <p:nvPicPr>
-          <p:cNvPr descr="Logo2.pngGoogle Shape;37;p4" id="96" name="Google Shape;96;p17"/>
+          <p:cNvPr descr="Logo2.pngGoogle Shape;37;p4" id="107" name="Google Shape;107;p19"/>
           <p:cNvPicPr preferRelativeResize="0"/>
           <p:nvPr/>
         </p:nvPicPr>
@@ -13783,7 +13783,7 @@
       </p:pic>
       <p:sp>
         <p:nvSpPr>
-          <p:cNvPr id="97" name="Google Shape;97;p17"/>
+          <p:cNvPr id="108" name="Google Shape;108;p19"/>
           <p:cNvSpPr txBox="1"/>
           <p:nvPr>
             <p:ph idx="12" type="sldNum"/>
@@ -13792,7 +13792,7 @@
         <p:spPr>
           <a:xfrm>
             <a:off x="11652438" y="6343529"/>
-            <a:ext cx="169330" cy="169330"/>
+            <a:ext cx="169196" cy="163996"/>
           </a:xfrm>
           <a:prstGeom prst="rect">
             <a:avLst/>
@@ -14080,7 +14080,7 @@
     </p:bg>
     <p:spTree>
       <p:nvGrpSpPr>
-        <p:cNvPr id="98" name="Shape 98"/>
+        <p:cNvPr id="109" name="Shape 109"/>
         <p:cNvGrpSpPr/>
         <p:nvPr/>
       </p:nvGrpSpPr>
@@ -14094,7 +14094,7 @@
       </p:grpSpPr>
       <p:sp>
         <p:nvSpPr>
-          <p:cNvPr id="99" name="Google Shape;99;p18"/>
+          <p:cNvPr id="110" name="Google Shape;110;p20"/>
           <p:cNvSpPr txBox="1"/>
           <p:nvPr>
             <p:ph type="title"/>
@@ -14278,14 +14278,14 @@
       </p:sp>
       <p:sp>
         <p:nvSpPr>
-          <p:cNvPr id="100" name="Google Shape;100;p18"/>
+          <p:cNvPr id="111" name="Google Shape;111;p20"/>
           <p:cNvSpPr/>
           <p:nvPr/>
         </p:nvSpPr>
         <p:spPr>
           <a:xfrm>
             <a:off x="6108981" y="0"/>
-            <a:ext cx="6082649" cy="6857828"/>
+            <a:ext cx="6082648" cy="6857828"/>
           </a:xfrm>
           <a:prstGeom prst="rect">
             <a:avLst/>
@@ -14299,7 +14299,7 @@
                 <a:srgbClr val="493691"/>
               </a:gs>
             </a:gsLst>
-            <a:lin ang="16198661" scaled="0"/>
+            <a:lin ang="16198662" scaled="0"/>
           </a:gradFill>
           <a:ln>
             <a:noFill/>
@@ -14345,7 +14345,7 @@
       </p:sp>
       <p:sp>
         <p:nvSpPr>
-          <p:cNvPr id="101" name="Google Shape;101;p18"/>
+          <p:cNvPr id="112" name="Google Shape;112;p20"/>
           <p:cNvSpPr txBox="1"/>
           <p:nvPr>
             <p:ph idx="1" type="body"/>
@@ -14354,7 +14354,7 @@
         <p:spPr>
           <a:xfrm>
             <a:off x="369989" y="371791"/>
-            <a:ext cx="5110275" cy="183197"/>
+            <a:ext cx="5110272" cy="183195"/>
           </a:xfrm>
           <a:prstGeom prst="rect">
             <a:avLst/>
@@ -14541,14 +14541,14 @@
       </p:sp>
       <p:cxnSp>
         <p:nvCxnSpPr>
-          <p:cNvPr id="102" name="Google Shape;102;p18"/>
+          <p:cNvPr id="113" name="Google Shape;113;p20"/>
           <p:cNvCxnSpPr/>
           <p:nvPr/>
         </p:nvCxnSpPr>
         <p:spPr>
           <a:xfrm rot="10800000">
-            <a:off x="6113894" y="1770222"/>
-            <a:ext cx="6082649" cy="1"/>
+            <a:off x="6113895" y="1770224"/>
+            <a:ext cx="6082648" cy="0"/>
           </a:xfrm>
           <a:prstGeom prst="straightConnector1">
             <a:avLst/>
@@ -14567,14 +14567,14 @@
       </p:cxnSp>
       <p:cxnSp>
         <p:nvCxnSpPr>
-          <p:cNvPr id="103" name="Google Shape;103;p18"/>
+          <p:cNvPr id="114" name="Google Shape;114;p20"/>
           <p:cNvCxnSpPr/>
           <p:nvPr/>
         </p:nvCxnSpPr>
         <p:spPr>
           <a:xfrm rot="10800000">
-            <a:off x="6113894" y="2419557"/>
-            <a:ext cx="6082649" cy="1"/>
+            <a:off x="6113895" y="2419558"/>
+            <a:ext cx="6082648" cy="0"/>
           </a:xfrm>
           <a:prstGeom prst="straightConnector1">
             <a:avLst/>
@@ -14593,14 +14593,14 @@
       </p:cxnSp>
       <p:cxnSp>
         <p:nvCxnSpPr>
-          <p:cNvPr id="104" name="Google Shape;104;p18"/>
+          <p:cNvPr id="115" name="Google Shape;115;p20"/>
           <p:cNvCxnSpPr/>
           <p:nvPr/>
         </p:nvCxnSpPr>
         <p:spPr>
           <a:xfrm rot="10800000">
-            <a:off x="6113894" y="3068961"/>
-            <a:ext cx="6082649" cy="1"/>
+            <a:off x="6113895" y="3068962"/>
+            <a:ext cx="6082648" cy="0"/>
           </a:xfrm>
           <a:prstGeom prst="straightConnector1">
             <a:avLst/>
@@ -14619,14 +14619,14 @@
       </p:cxnSp>
       <p:cxnSp>
         <p:nvCxnSpPr>
-          <p:cNvPr id="105" name="Google Shape;105;p18"/>
+          <p:cNvPr id="116" name="Google Shape;116;p20"/>
           <p:cNvCxnSpPr/>
           <p:nvPr/>
         </p:nvCxnSpPr>
         <p:spPr>
           <a:xfrm rot="10800000">
-            <a:off x="6113894" y="3718360"/>
-            <a:ext cx="6082649" cy="1"/>
+            <a:off x="6113895" y="3718362"/>
+            <a:ext cx="6082648" cy="0"/>
           </a:xfrm>
           <a:prstGeom prst="straightConnector1">
             <a:avLst/>
@@ -14645,14 +14645,14 @@
       </p:cxnSp>
       <p:cxnSp>
         <p:nvCxnSpPr>
-          <p:cNvPr id="106" name="Google Shape;106;p18"/>
+          <p:cNvPr id="117" name="Google Shape;117;p20"/>
           <p:cNvCxnSpPr/>
           <p:nvPr/>
         </p:nvCxnSpPr>
         <p:spPr>
           <a:xfrm rot="10800000">
-            <a:off x="6113894" y="4367765"/>
-            <a:ext cx="6082649" cy="1"/>
+            <a:off x="6113895" y="4367767"/>
+            <a:ext cx="6082648" cy="0"/>
           </a:xfrm>
           <a:prstGeom prst="straightConnector1">
             <a:avLst/>
@@ -14671,14 +14671,14 @@
       </p:cxnSp>
       <p:cxnSp>
         <p:nvCxnSpPr>
-          <p:cNvPr id="107" name="Google Shape;107;p18"/>
+          <p:cNvPr id="118" name="Google Shape;118;p20"/>
           <p:cNvCxnSpPr/>
           <p:nvPr/>
         </p:nvCxnSpPr>
         <p:spPr>
           <a:xfrm rot="10800000">
-            <a:off x="6113894" y="5017097"/>
-            <a:ext cx="6082649" cy="1"/>
+            <a:off x="6113895" y="5017098"/>
+            <a:ext cx="6082648" cy="0"/>
           </a:xfrm>
           <a:prstGeom prst="straightConnector1">
             <a:avLst/>
@@ -14697,14 +14697,14 @@
       </p:cxnSp>
       <p:cxnSp>
         <p:nvCxnSpPr>
-          <p:cNvPr id="108" name="Google Shape;108;p18"/>
+          <p:cNvPr id="119" name="Google Shape;119;p20"/>
           <p:cNvCxnSpPr/>
           <p:nvPr/>
         </p:nvCxnSpPr>
         <p:spPr>
           <a:xfrm rot="10800000">
-            <a:off x="6113894" y="5666502"/>
-            <a:ext cx="6082649" cy="1"/>
+            <a:off x="6113895" y="5666504"/>
+            <a:ext cx="6082648" cy="0"/>
           </a:xfrm>
           <a:prstGeom prst="straightConnector1">
             <a:avLst/>
@@ -14723,14 +14723,14 @@
       </p:cxnSp>
       <p:cxnSp>
         <p:nvCxnSpPr>
-          <p:cNvPr id="109" name="Google Shape;109;p18"/>
+          <p:cNvPr id="120" name="Google Shape;120;p20"/>
           <p:cNvCxnSpPr/>
           <p:nvPr/>
         </p:nvCxnSpPr>
         <p:spPr>
           <a:xfrm rot="10800000">
-            <a:off x="6113894" y="6315802"/>
-            <a:ext cx="6082649" cy="1"/>
+            <a:off x="6113895" y="6315803"/>
+            <a:ext cx="6082648" cy="0"/>
           </a:xfrm>
           <a:prstGeom prst="straightConnector1">
             <a:avLst/>
@@ -14749,14 +14749,14 @@
       </p:cxnSp>
       <p:cxnSp>
         <p:nvCxnSpPr>
-          <p:cNvPr id="110" name="Google Shape;110;p18"/>
+          <p:cNvPr id="121" name="Google Shape;121;p20"/>
           <p:cNvCxnSpPr/>
           <p:nvPr/>
         </p:nvCxnSpPr>
         <p:spPr>
           <a:xfrm rot="10800000">
-            <a:off x="6113894" y="471415"/>
-            <a:ext cx="6082649" cy="1"/>
+            <a:off x="6113895" y="471416"/>
+            <a:ext cx="6082648" cy="0"/>
           </a:xfrm>
           <a:prstGeom prst="straightConnector1">
             <a:avLst/>
@@ -14775,14 +14775,14 @@
       </p:cxnSp>
       <p:cxnSp>
         <p:nvCxnSpPr>
-          <p:cNvPr id="111" name="Google Shape;111;p18"/>
+          <p:cNvPr id="122" name="Google Shape;122;p20"/>
           <p:cNvCxnSpPr/>
           <p:nvPr/>
         </p:nvCxnSpPr>
         <p:spPr>
           <a:xfrm rot="10800000">
-            <a:off x="6113894" y="1120819"/>
-            <a:ext cx="6082649" cy="1"/>
+            <a:off x="6113895" y="1120820"/>
+            <a:ext cx="6082648" cy="0"/>
           </a:xfrm>
           <a:prstGeom prst="straightConnector1">
             <a:avLst/>
@@ -14801,28 +14801,28 @@
       </p:cxnSp>
       <p:grpSp>
         <p:nvGrpSpPr>
-          <p:cNvPr id="112" name="Google Shape;112;p18"/>
+          <p:cNvPr id="123" name="Google Shape;123;p20"/>
           <p:cNvGrpSpPr/>
           <p:nvPr/>
         </p:nvGrpSpPr>
         <p:grpSpPr>
           <a:xfrm>
-            <a:off x="6115350" y="-136"/>
-            <a:ext cx="5783159" cy="6857896"/>
-            <a:chOff x="-1" y="0"/>
-            <a:chExt cx="5783158" cy="6857894"/>
+            <a:off x="6115352" y="-136"/>
+            <a:ext cx="5783155" cy="6857828"/>
+            <a:chOff x="1" y="0"/>
+            <a:chExt cx="5783155" cy="6857828"/>
           </a:xfrm>
         </p:grpSpPr>
         <p:cxnSp>
           <p:nvCxnSpPr>
-            <p:cNvPr id="113" name="Google Shape;113;p18"/>
+            <p:cNvPr id="124" name="Google Shape;124;p20"/>
             <p:cNvCxnSpPr/>
             <p:nvPr/>
           </p:nvCxnSpPr>
           <p:spPr>
-            <a:xfrm flipH="1">
-              <a:off x="-1" y="0"/>
-              <a:ext cx="3" cy="6857894"/>
+            <a:xfrm>
+              <a:off x="1" y="0"/>
+              <a:ext cx="0" cy="6857828"/>
             </a:xfrm>
             <a:prstGeom prst="straightConnector1">
               <a:avLst/>
@@ -14841,14 +14841,14 @@
         </p:cxnSp>
         <p:cxnSp>
           <p:nvCxnSpPr>
-            <p:cNvPr id="114" name="Google Shape;114;p18"/>
+            <p:cNvPr id="125" name="Google Shape;125;p20"/>
             <p:cNvCxnSpPr/>
             <p:nvPr/>
           </p:nvCxnSpPr>
           <p:spPr>
-            <a:xfrm flipH="1">
-              <a:off x="642536" y="0"/>
-              <a:ext cx="1" cy="6857894"/>
+            <a:xfrm>
+              <a:off x="642537" y="0"/>
+              <a:ext cx="0" cy="6857828"/>
             </a:xfrm>
             <a:prstGeom prst="straightConnector1">
               <a:avLst/>
@@ -14867,14 +14867,14 @@
         </p:cxnSp>
         <p:cxnSp>
           <p:nvCxnSpPr>
-            <p:cNvPr id="115" name="Google Shape;115;p18"/>
+            <p:cNvPr id="126" name="Google Shape;126;p20"/>
             <p:cNvCxnSpPr/>
             <p:nvPr/>
           </p:nvCxnSpPr>
           <p:spPr>
-            <a:xfrm flipH="1">
-              <a:off x="1285073" y="0"/>
-              <a:ext cx="1" cy="6857894"/>
+            <a:xfrm>
+              <a:off x="1285075" y="0"/>
+              <a:ext cx="0" cy="6857828"/>
             </a:xfrm>
             <a:prstGeom prst="straightConnector1">
               <a:avLst/>
@@ -14893,14 +14893,14 @@
         </p:cxnSp>
         <p:cxnSp>
           <p:nvCxnSpPr>
-            <p:cNvPr id="116" name="Google Shape;116;p18"/>
+            <p:cNvPr id="127" name="Google Shape;127;p20"/>
             <p:cNvCxnSpPr/>
             <p:nvPr/>
           </p:nvCxnSpPr>
           <p:spPr>
-            <a:xfrm flipH="1">
-              <a:off x="1927610" y="0"/>
-              <a:ext cx="1" cy="6857894"/>
+            <a:xfrm>
+              <a:off x="1927612" y="0"/>
+              <a:ext cx="0" cy="6857828"/>
             </a:xfrm>
             <a:prstGeom prst="straightConnector1">
               <a:avLst/>
@@ -14919,14 +14919,14 @@
         </p:cxnSp>
         <p:cxnSp>
           <p:nvCxnSpPr>
-            <p:cNvPr id="117" name="Google Shape;117;p18"/>
+            <p:cNvPr id="128" name="Google Shape;128;p20"/>
             <p:cNvCxnSpPr/>
             <p:nvPr/>
           </p:nvCxnSpPr>
           <p:spPr>
-            <a:xfrm flipH="1">
-              <a:off x="2570146" y="0"/>
-              <a:ext cx="1" cy="6857894"/>
+            <a:xfrm>
+              <a:off x="2570148" y="0"/>
+              <a:ext cx="0" cy="6857828"/>
             </a:xfrm>
             <a:prstGeom prst="straightConnector1">
               <a:avLst/>
@@ -14945,14 +14945,14 @@
         </p:cxnSp>
         <p:cxnSp>
           <p:nvCxnSpPr>
-            <p:cNvPr id="118" name="Google Shape;118;p18"/>
+            <p:cNvPr id="129" name="Google Shape;129;p20"/>
             <p:cNvCxnSpPr/>
             <p:nvPr/>
           </p:nvCxnSpPr>
           <p:spPr>
-            <a:xfrm flipH="1">
-              <a:off x="3212684" y="0"/>
-              <a:ext cx="1" cy="6857894"/>
+            <a:xfrm>
+              <a:off x="3212685" y="0"/>
+              <a:ext cx="0" cy="6857828"/>
             </a:xfrm>
             <a:prstGeom prst="straightConnector1">
               <a:avLst/>
@@ -14971,14 +14971,14 @@
         </p:cxnSp>
         <p:cxnSp>
           <p:nvCxnSpPr>
-            <p:cNvPr id="119" name="Google Shape;119;p18"/>
+            <p:cNvPr id="130" name="Google Shape;130;p20"/>
             <p:cNvCxnSpPr/>
             <p:nvPr/>
           </p:nvCxnSpPr>
           <p:spPr>
-            <a:xfrm flipH="1">
-              <a:off x="3855328" y="0"/>
-              <a:ext cx="1" cy="6857894"/>
+            <a:xfrm>
+              <a:off x="3855329" y="0"/>
+              <a:ext cx="0" cy="6857828"/>
             </a:xfrm>
             <a:prstGeom prst="straightConnector1">
               <a:avLst/>
@@ -14997,14 +14997,14 @@
         </p:cxnSp>
         <p:cxnSp>
           <p:nvCxnSpPr>
-            <p:cNvPr id="120" name="Google Shape;120;p18"/>
+            <p:cNvPr id="131" name="Google Shape;131;p20"/>
             <p:cNvCxnSpPr/>
             <p:nvPr/>
           </p:nvCxnSpPr>
           <p:spPr>
-            <a:xfrm flipH="1">
-              <a:off x="4497863" y="0"/>
-              <a:ext cx="1" cy="6857894"/>
+            <a:xfrm>
+              <a:off x="4497865" y="0"/>
+              <a:ext cx="0" cy="6857828"/>
             </a:xfrm>
             <a:prstGeom prst="straightConnector1">
               <a:avLst/>
@@ -15023,14 +15023,14 @@
         </p:cxnSp>
         <p:cxnSp>
           <p:nvCxnSpPr>
-            <p:cNvPr id="121" name="Google Shape;121;p18"/>
+            <p:cNvPr id="132" name="Google Shape;132;p20"/>
             <p:cNvCxnSpPr/>
             <p:nvPr/>
           </p:nvCxnSpPr>
           <p:spPr>
-            <a:xfrm flipH="1">
-              <a:off x="5140522" y="0"/>
-              <a:ext cx="1" cy="6857894"/>
+            <a:xfrm>
+              <a:off x="5140523" y="0"/>
+              <a:ext cx="0" cy="6857828"/>
             </a:xfrm>
             <a:prstGeom prst="straightConnector1">
               <a:avLst/>
@@ -15049,14 +15049,14 @@
         </p:cxnSp>
         <p:cxnSp>
           <p:nvCxnSpPr>
-            <p:cNvPr id="122" name="Google Shape;122;p18"/>
+            <p:cNvPr id="133" name="Google Shape;133;p20"/>
             <p:cNvCxnSpPr/>
             <p:nvPr/>
           </p:nvCxnSpPr>
           <p:spPr>
-            <a:xfrm flipH="1">
-              <a:off x="5783155" y="0"/>
-              <a:ext cx="1" cy="6857894"/>
+            <a:xfrm>
+              <a:off x="5783157" y="0"/>
+              <a:ext cx="0" cy="6857828"/>
             </a:xfrm>
             <a:prstGeom prst="straightConnector1">
               <a:avLst/>
@@ -15076,7 +15076,7 @@
       </p:grpSp>
       <p:sp>
         <p:nvSpPr>
-          <p:cNvPr id="123" name="Google Shape;123;p18"/>
+          <p:cNvPr id="134" name="Google Shape;134;p20"/>
           <p:cNvSpPr txBox="1"/>
           <p:nvPr>
             <p:ph idx="12" type="sldNum"/>
@@ -15085,7 +15085,7 @@
         <p:spPr>
           <a:xfrm>
             <a:off x="5892653" y="6169928"/>
-            <a:ext cx="2844729" cy="372525"/>
+            <a:ext cx="2844729" cy="369191"/>
           </a:xfrm>
           <a:prstGeom prst="rect">
             <a:avLst/>
@@ -15337,7 +15337,7 @@
     </p:bg>
     <p:spTree>
       <p:nvGrpSpPr>
-        <p:cNvPr id="124" name="Shape 124"/>
+        <p:cNvPr id="135" name="Shape 135"/>
         <p:cNvGrpSpPr/>
         <p:nvPr/>
       </p:nvGrpSpPr>
@@ -15351,14 +15351,14 @@
       </p:grpSpPr>
       <p:sp>
         <p:nvSpPr>
-          <p:cNvPr id="125" name="Google Shape;125;p19"/>
+          <p:cNvPr id="136" name="Google Shape;136;p21"/>
           <p:cNvSpPr/>
           <p:nvPr/>
         </p:nvSpPr>
         <p:spPr>
           <a:xfrm rot="10800000">
-            <a:off x="375889" y="368323"/>
-            <a:ext cx="11451715" cy="6131848"/>
+            <a:off x="375891" y="368324"/>
+            <a:ext cx="11451714" cy="6131847"/>
           </a:xfrm>
           <a:prstGeom prst="roundRect">
             <a:avLst>
@@ -15420,7 +15420,7 @@
       </p:sp>
       <p:sp>
         <p:nvSpPr>
-          <p:cNvPr id="126" name="Google Shape;126;p19"/>
+          <p:cNvPr id="137" name="Google Shape;137;p21"/>
           <p:cNvSpPr txBox="1"/>
           <p:nvPr>
             <p:ph idx="1" type="body"/>
@@ -15429,7 +15429,7 @@
         <p:spPr>
           <a:xfrm>
             <a:off x="1094643" y="5230676"/>
-            <a:ext cx="7812207" cy="603586"/>
+            <a:ext cx="7812205" cy="603585"/>
           </a:xfrm>
           <a:prstGeom prst="rect">
             <a:avLst/>
@@ -15621,14 +15621,14 @@
       </p:sp>
       <p:cxnSp>
         <p:nvCxnSpPr>
-          <p:cNvPr id="127" name="Google Shape;127;p19"/>
+          <p:cNvPr id="138" name="Google Shape;138;p21"/>
           <p:cNvCxnSpPr/>
           <p:nvPr/>
         </p:nvCxnSpPr>
         <p:spPr>
           <a:xfrm>
             <a:off x="734482" y="1056740"/>
-            <a:ext cx="10736931" cy="1"/>
+            <a:ext cx="10736931" cy="0"/>
           </a:xfrm>
           <a:prstGeom prst="straightConnector1">
             <a:avLst/>
@@ -15647,14 +15647,14 @@
       </p:cxnSp>
       <p:cxnSp>
         <p:nvCxnSpPr>
-          <p:cNvPr id="128" name="Google Shape;128;p19"/>
+          <p:cNvPr id="139" name="Google Shape;139;p21"/>
           <p:cNvCxnSpPr/>
           <p:nvPr/>
         </p:nvCxnSpPr>
         <p:spPr>
           <a:xfrm>
             <a:off x="734482" y="6028883"/>
-            <a:ext cx="10726530" cy="1"/>
+            <a:ext cx="10726532" cy="0"/>
           </a:xfrm>
           <a:prstGeom prst="straightConnector1">
             <a:avLst/>
@@ -15673,7 +15673,7 @@
       </p:cxnSp>
       <p:sp>
         <p:nvSpPr>
-          <p:cNvPr id="129" name="Google Shape;129;p19"/>
+          <p:cNvPr id="140" name="Google Shape;140;p21"/>
           <p:cNvSpPr txBox="1"/>
           <p:nvPr>
             <p:ph type="title"/>
@@ -15682,7 +15682,7 @@
         <p:spPr>
           <a:xfrm>
             <a:off x="1060672" y="2992532"/>
-            <a:ext cx="8162197" cy="1880754"/>
+            <a:ext cx="8162196" cy="1880753"/>
           </a:xfrm>
           <a:prstGeom prst="rect">
             <a:avLst/>
@@ -15857,7 +15857,7 @@
       </p:sp>
       <p:pic>
         <p:nvPicPr>
-          <p:cNvPr descr="Logo-white.pngGoogle Shape;16;p2" id="130" name="Google Shape;130;p19"/>
+          <p:cNvPr descr="Logo-white.pngGoogle Shape;16;p2" id="141" name="Google Shape;141;p21"/>
           <p:cNvPicPr preferRelativeResize="0"/>
           <p:nvPr/>
         </p:nvPicPr>
@@ -15884,7 +15884,7 @@
       </p:pic>
       <p:sp>
         <p:nvSpPr>
-          <p:cNvPr id="131" name="Google Shape;131;p19"/>
+          <p:cNvPr id="142" name="Google Shape;142;p21"/>
           <p:cNvSpPr txBox="1"/>
           <p:nvPr>
             <p:ph idx="12" type="sldNum"/>
@@ -15893,7 +15893,7 @@
         <p:spPr>
           <a:xfrm>
             <a:off x="5892653" y="6169928"/>
-            <a:ext cx="2844729" cy="372525"/>
+            <a:ext cx="2844729" cy="369191"/>
           </a:xfrm>
           <a:prstGeom prst="rect">
             <a:avLst/>
@@ -16138,7 +16138,7 @@
   <p:cSld name="CUSTOM_21_1_1">
     <p:spTree>
       <p:nvGrpSpPr>
-        <p:cNvPr id="132" name="Shape 132"/>
+        <p:cNvPr id="143" name="Shape 143"/>
         <p:cNvGrpSpPr/>
         <p:nvPr/>
       </p:nvGrpSpPr>
@@ -16152,7 +16152,7 @@
       </p:grpSpPr>
       <p:sp>
         <p:nvSpPr>
-          <p:cNvPr id="133" name="Google Shape;133;p20"/>
+          <p:cNvPr id="144" name="Google Shape;144;p22"/>
           <p:cNvSpPr txBox="1"/>
           <p:nvPr>
             <p:ph type="title"/>
@@ -16161,7 +16161,7 @@
         <p:spPr>
           <a:xfrm>
             <a:off x="369989" y="554985"/>
-            <a:ext cx="11451715" cy="1179972"/>
+            <a:ext cx="11451714" cy="1179970"/>
           </a:xfrm>
           <a:prstGeom prst="rect">
             <a:avLst/>
@@ -16335,7 +16335,7 @@
       </p:sp>
       <p:sp>
         <p:nvSpPr>
-          <p:cNvPr id="134" name="Google Shape;134;p20"/>
+          <p:cNvPr id="145" name="Google Shape;145;p22"/>
           <p:cNvSpPr txBox="1"/>
           <p:nvPr>
             <p:ph idx="1" type="body"/>
@@ -16344,7 +16344,7 @@
         <p:spPr>
           <a:xfrm>
             <a:off x="369989" y="371791"/>
-            <a:ext cx="5110275" cy="183197"/>
+            <a:ext cx="5110272" cy="183195"/>
           </a:xfrm>
           <a:prstGeom prst="rect">
             <a:avLst/>
@@ -16511,7 +16511,7 @@
       </p:sp>
       <p:pic>
         <p:nvPicPr>
-          <p:cNvPr descr="Logo-white.pngGoogle Shape;42;p5" id="135" name="Google Shape;135;p20"/>
+          <p:cNvPr descr="Logo-white.pngGoogle Shape;42;p5" id="146" name="Google Shape;146;p22"/>
           <p:cNvPicPr preferRelativeResize="0"/>
           <p:nvPr/>
         </p:nvPicPr>
@@ -16538,7 +16538,7 @@
       </p:pic>
       <p:sp>
         <p:nvSpPr>
-          <p:cNvPr id="136" name="Google Shape;136;p20"/>
+          <p:cNvPr id="147" name="Google Shape;147;p22"/>
           <p:cNvSpPr txBox="1"/>
           <p:nvPr>
             <p:ph idx="12" type="sldNum"/>
@@ -16547,7 +16547,7 @@
         <p:spPr>
           <a:xfrm>
             <a:off x="11652438" y="6343529"/>
-            <a:ext cx="169330" cy="169330"/>
+            <a:ext cx="169196" cy="163996"/>
           </a:xfrm>
           <a:prstGeom prst="rect">
             <a:avLst/>
@@ -16835,7 +16835,7 @@
     </p:bg>
     <p:spTree>
       <p:nvGrpSpPr>
-        <p:cNvPr id="137" name="Shape 137"/>
+        <p:cNvPr id="148" name="Shape 148"/>
         <p:cNvGrpSpPr/>
         <p:nvPr/>
       </p:nvGrpSpPr>
@@ -16849,14 +16849,14 @@
       </p:grpSpPr>
       <p:cxnSp>
         <p:nvCxnSpPr>
-          <p:cNvPr id="138" name="Google Shape;138;p21"/>
+          <p:cNvPr id="149" name="Google Shape;149;p23"/>
           <p:cNvCxnSpPr/>
           <p:nvPr/>
         </p:nvCxnSpPr>
         <p:spPr>
           <a:xfrm rot="10800000">
-            <a:off x="-25234" y="471426"/>
-            <a:ext cx="12208496" cy="1"/>
+            <a:off x="-25233" y="471427"/>
+            <a:ext cx="12208495" cy="0"/>
           </a:xfrm>
           <a:prstGeom prst="straightConnector1">
             <a:avLst/>
@@ -16875,14 +16875,14 @@
       </p:cxnSp>
       <p:cxnSp>
         <p:nvCxnSpPr>
-          <p:cNvPr id="139" name="Google Shape;139;p21"/>
+          <p:cNvPr id="150" name="Google Shape;150;p23"/>
           <p:cNvCxnSpPr/>
           <p:nvPr/>
         </p:nvCxnSpPr>
         <p:spPr>
           <a:xfrm rot="10800000">
-            <a:off x="-25234" y="1120828"/>
-            <a:ext cx="12208496" cy="1"/>
+            <a:off x="-25233" y="1120829"/>
+            <a:ext cx="12208495" cy="0"/>
           </a:xfrm>
           <a:prstGeom prst="straightConnector1">
             <a:avLst/>
@@ -16901,14 +16901,14 @@
       </p:cxnSp>
       <p:cxnSp>
         <p:nvCxnSpPr>
-          <p:cNvPr id="140" name="Google Shape;140;p21"/>
+          <p:cNvPr id="151" name="Google Shape;151;p23"/>
           <p:cNvCxnSpPr/>
           <p:nvPr/>
         </p:nvCxnSpPr>
         <p:spPr>
           <a:xfrm rot="10800000">
-            <a:off x="-25234" y="1770229"/>
-            <a:ext cx="12208496" cy="1"/>
+            <a:off x="-25233" y="1770230"/>
+            <a:ext cx="12208495" cy="0"/>
           </a:xfrm>
           <a:prstGeom prst="straightConnector1">
             <a:avLst/>
@@ -16927,14 +16927,14 @@
       </p:cxnSp>
       <p:cxnSp>
         <p:nvCxnSpPr>
-          <p:cNvPr id="141" name="Google Shape;141;p21"/>
+          <p:cNvPr id="152" name="Google Shape;152;p23"/>
           <p:cNvCxnSpPr/>
           <p:nvPr/>
         </p:nvCxnSpPr>
         <p:spPr>
           <a:xfrm rot="10800000">
-            <a:off x="-25234" y="2419561"/>
-            <a:ext cx="12208496" cy="1"/>
+            <a:off x="-25233" y="2419562"/>
+            <a:ext cx="12208495" cy="0"/>
           </a:xfrm>
           <a:prstGeom prst="straightConnector1">
             <a:avLst/>
@@ -16953,14 +16953,14 @@
       </p:cxnSp>
       <p:cxnSp>
         <p:nvCxnSpPr>
-          <p:cNvPr id="142" name="Google Shape;142;p21"/>
+          <p:cNvPr id="153" name="Google Shape;153;p23"/>
           <p:cNvCxnSpPr/>
           <p:nvPr/>
         </p:nvCxnSpPr>
         <p:spPr>
           <a:xfrm rot="10800000">
-            <a:off x="-25234" y="3068963"/>
-            <a:ext cx="12208496" cy="1"/>
+            <a:off x="-25233" y="3068965"/>
+            <a:ext cx="12208495" cy="0"/>
           </a:xfrm>
           <a:prstGeom prst="straightConnector1">
             <a:avLst/>
@@ -16979,28 +16979,28 @@
       </p:cxnSp>
       <p:grpSp>
         <p:nvGrpSpPr>
-          <p:cNvPr id="143" name="Google Shape;143;p21"/>
+          <p:cNvPr id="154" name="Google Shape;154;p23"/>
           <p:cNvGrpSpPr/>
           <p:nvPr/>
         </p:nvGrpSpPr>
         <p:grpSpPr>
           <a:xfrm>
-            <a:off x="-4701" y="-136"/>
-            <a:ext cx="12208637" cy="6857898"/>
-            <a:chOff x="-1" y="0"/>
-            <a:chExt cx="12208637" cy="6857895"/>
+            <a:off x="-4699" y="-136"/>
+            <a:ext cx="12208632" cy="6857828"/>
+            <a:chOff x="1" y="0"/>
+            <a:chExt cx="12208632" cy="6857828"/>
           </a:xfrm>
         </p:grpSpPr>
         <p:cxnSp>
           <p:nvCxnSpPr>
-            <p:cNvPr id="144" name="Google Shape;144;p21"/>
+            <p:cNvPr id="155" name="Google Shape;155;p23"/>
             <p:cNvCxnSpPr/>
             <p:nvPr/>
           </p:nvCxnSpPr>
           <p:spPr>
-            <a:xfrm flipH="1">
-              <a:off x="642536" y="0"/>
-              <a:ext cx="1" cy="6857894"/>
+            <a:xfrm>
+              <a:off x="642537" y="0"/>
+              <a:ext cx="0" cy="6857828"/>
             </a:xfrm>
             <a:prstGeom prst="straightConnector1">
               <a:avLst/>
@@ -17019,14 +17019,14 @@
         </p:cxnSp>
         <p:cxnSp>
           <p:nvCxnSpPr>
-            <p:cNvPr id="145" name="Google Shape;145;p21"/>
+            <p:cNvPr id="156" name="Google Shape;156;p23"/>
             <p:cNvCxnSpPr/>
             <p:nvPr/>
           </p:nvCxnSpPr>
           <p:spPr>
-            <a:xfrm flipH="1">
-              <a:off x="1285073" y="0"/>
-              <a:ext cx="1" cy="6857894"/>
+            <a:xfrm>
+              <a:off x="1285075" y="0"/>
+              <a:ext cx="0" cy="6857828"/>
             </a:xfrm>
             <a:prstGeom prst="straightConnector1">
               <a:avLst/>
@@ -17045,14 +17045,14 @@
         </p:cxnSp>
         <p:cxnSp>
           <p:nvCxnSpPr>
-            <p:cNvPr id="146" name="Google Shape;146;p21"/>
+            <p:cNvPr id="157" name="Google Shape;157;p23"/>
             <p:cNvCxnSpPr/>
             <p:nvPr/>
           </p:nvCxnSpPr>
           <p:spPr>
-            <a:xfrm flipH="1">
-              <a:off x="1927610" y="0"/>
-              <a:ext cx="1" cy="6857894"/>
+            <a:xfrm>
+              <a:off x="1927612" y="0"/>
+              <a:ext cx="0" cy="6857828"/>
             </a:xfrm>
             <a:prstGeom prst="straightConnector1">
               <a:avLst/>
@@ -17071,14 +17071,14 @@
         </p:cxnSp>
         <p:cxnSp>
           <p:nvCxnSpPr>
-            <p:cNvPr id="147" name="Google Shape;147;p21"/>
+            <p:cNvPr id="158" name="Google Shape;158;p23"/>
             <p:cNvCxnSpPr/>
             <p:nvPr/>
           </p:nvCxnSpPr>
           <p:spPr>
-            <a:xfrm flipH="1">
-              <a:off x="2570146" y="0"/>
-              <a:ext cx="1" cy="6857894"/>
+            <a:xfrm>
+              <a:off x="2570148" y="0"/>
+              <a:ext cx="0" cy="6857828"/>
             </a:xfrm>
             <a:prstGeom prst="straightConnector1">
               <a:avLst/>
@@ -17097,14 +17097,14 @@
         </p:cxnSp>
         <p:cxnSp>
           <p:nvCxnSpPr>
-            <p:cNvPr id="148" name="Google Shape;148;p21"/>
+            <p:cNvPr id="159" name="Google Shape;159;p23"/>
             <p:cNvCxnSpPr/>
             <p:nvPr/>
           </p:nvCxnSpPr>
           <p:spPr>
-            <a:xfrm flipH="1">
-              <a:off x="3212685" y="0"/>
-              <a:ext cx="1" cy="6857894"/>
+            <a:xfrm>
+              <a:off x="3212686" y="0"/>
+              <a:ext cx="0" cy="6857828"/>
             </a:xfrm>
             <a:prstGeom prst="straightConnector1">
               <a:avLst/>
@@ -17123,14 +17123,14 @@
         </p:cxnSp>
         <p:cxnSp>
           <p:nvCxnSpPr>
-            <p:cNvPr id="149" name="Google Shape;149;p21"/>
+            <p:cNvPr id="160" name="Google Shape;160;p23"/>
             <p:cNvCxnSpPr/>
             <p:nvPr/>
           </p:nvCxnSpPr>
           <p:spPr>
-            <a:xfrm flipH="1">
-              <a:off x="3855221" y="0"/>
-              <a:ext cx="1" cy="6857894"/>
+            <a:xfrm>
+              <a:off x="3855222" y="0"/>
+              <a:ext cx="0" cy="6857828"/>
             </a:xfrm>
             <a:prstGeom prst="straightConnector1">
               <a:avLst/>
@@ -17149,14 +17149,14 @@
         </p:cxnSp>
         <p:cxnSp>
           <p:nvCxnSpPr>
-            <p:cNvPr id="150" name="Google Shape;150;p21"/>
+            <p:cNvPr id="161" name="Google Shape;161;p23"/>
             <p:cNvCxnSpPr/>
             <p:nvPr/>
           </p:nvCxnSpPr>
           <p:spPr>
-            <a:xfrm flipH="1">
-              <a:off x="-1" y="0"/>
-              <a:ext cx="3" cy="6857894"/>
+            <a:xfrm>
+              <a:off x="1" y="0"/>
+              <a:ext cx="0" cy="6857828"/>
             </a:xfrm>
             <a:prstGeom prst="straightConnector1">
               <a:avLst/>
@@ -17175,14 +17175,14 @@
         </p:cxnSp>
         <p:cxnSp>
           <p:nvCxnSpPr>
-            <p:cNvPr id="151" name="Google Shape;151;p21"/>
+            <p:cNvPr id="162" name="Google Shape;162;p23"/>
             <p:cNvCxnSpPr/>
             <p:nvPr/>
           </p:nvCxnSpPr>
           <p:spPr>
-            <a:xfrm flipH="1">
-              <a:off x="4497758" y="0"/>
-              <a:ext cx="1" cy="6857894"/>
+            <a:xfrm>
+              <a:off x="4497759" y="0"/>
+              <a:ext cx="0" cy="6857828"/>
             </a:xfrm>
             <a:prstGeom prst="straightConnector1">
               <a:avLst/>
@@ -17201,14 +17201,14 @@
         </p:cxnSp>
         <p:cxnSp>
           <p:nvCxnSpPr>
-            <p:cNvPr id="152" name="Google Shape;152;p21"/>
+            <p:cNvPr id="163" name="Google Shape;163;p23"/>
             <p:cNvCxnSpPr/>
             <p:nvPr/>
           </p:nvCxnSpPr>
           <p:spPr>
-            <a:xfrm flipH="1">
-              <a:off x="5140295" y="0"/>
-              <a:ext cx="1" cy="6857894"/>
+            <a:xfrm>
+              <a:off x="5140297" y="0"/>
+              <a:ext cx="0" cy="6857828"/>
             </a:xfrm>
             <a:prstGeom prst="straightConnector1">
               <a:avLst/>
@@ -17227,14 +17227,14 @@
         </p:cxnSp>
         <p:cxnSp>
           <p:nvCxnSpPr>
-            <p:cNvPr id="153" name="Google Shape;153;p21"/>
+            <p:cNvPr id="164" name="Google Shape;164;p23"/>
             <p:cNvCxnSpPr/>
             <p:nvPr/>
           </p:nvCxnSpPr>
           <p:spPr>
-            <a:xfrm flipH="1">
-              <a:off x="5782831" y="0"/>
-              <a:ext cx="1" cy="6857894"/>
+            <a:xfrm>
+              <a:off x="5782833" y="0"/>
+              <a:ext cx="0" cy="6857828"/>
             </a:xfrm>
             <a:prstGeom prst="straightConnector1">
               <a:avLst/>
@@ -17253,14 +17253,14 @@
         </p:cxnSp>
         <p:cxnSp>
           <p:nvCxnSpPr>
-            <p:cNvPr id="154" name="Google Shape;154;p21"/>
+            <p:cNvPr id="165" name="Google Shape;165;p23"/>
             <p:cNvCxnSpPr/>
             <p:nvPr/>
           </p:nvCxnSpPr>
           <p:spPr>
-            <a:xfrm flipH="1">
-              <a:off x="6425369" y="0"/>
-              <a:ext cx="1" cy="6857894"/>
+            <a:xfrm>
+              <a:off x="6425370" y="0"/>
+              <a:ext cx="0" cy="6857828"/>
             </a:xfrm>
             <a:prstGeom prst="straightConnector1">
               <a:avLst/>
@@ -17279,14 +17279,14 @@
         </p:cxnSp>
         <p:cxnSp>
           <p:nvCxnSpPr>
-            <p:cNvPr id="155" name="Google Shape;155;p21"/>
+            <p:cNvPr id="166" name="Google Shape;166;p23"/>
             <p:cNvCxnSpPr/>
             <p:nvPr/>
           </p:nvCxnSpPr>
           <p:spPr>
-            <a:xfrm flipH="1">
-              <a:off x="7067906" y="0"/>
-              <a:ext cx="1" cy="6857894"/>
+            <a:xfrm>
+              <a:off x="7067907" y="0"/>
+              <a:ext cx="0" cy="6857828"/>
             </a:xfrm>
             <a:prstGeom prst="straightConnector1">
               <a:avLst/>
@@ -17305,14 +17305,14 @@
         </p:cxnSp>
         <p:cxnSp>
           <p:nvCxnSpPr>
-            <p:cNvPr id="156" name="Google Shape;156;p21"/>
+            <p:cNvPr id="167" name="Google Shape;167;p23"/>
             <p:cNvCxnSpPr/>
             <p:nvPr/>
           </p:nvCxnSpPr>
           <p:spPr>
-            <a:xfrm flipH="1">
-              <a:off x="7710443" y="0"/>
-              <a:ext cx="1" cy="6857894"/>
+            <a:xfrm>
+              <a:off x="7710444" y="0"/>
+              <a:ext cx="0" cy="6857828"/>
             </a:xfrm>
             <a:prstGeom prst="straightConnector1">
               <a:avLst/>
@@ -17331,14 +17331,14 @@
         </p:cxnSp>
         <p:cxnSp>
           <p:nvCxnSpPr>
-            <p:cNvPr id="157" name="Google Shape;157;p21"/>
+            <p:cNvPr id="168" name="Google Shape;168;p23"/>
             <p:cNvCxnSpPr/>
             <p:nvPr/>
           </p:nvCxnSpPr>
           <p:spPr>
-            <a:xfrm flipH="1">
-              <a:off x="8352979" y="0"/>
-              <a:ext cx="1" cy="6857894"/>
+            <a:xfrm>
+              <a:off x="8352980" y="0"/>
+              <a:ext cx="0" cy="6857828"/>
             </a:xfrm>
             <a:prstGeom prst="straightConnector1">
               <a:avLst/>
@@ -17357,14 +17357,14 @@
         </p:cxnSp>
         <p:cxnSp>
           <p:nvCxnSpPr>
-            <p:cNvPr id="158" name="Google Shape;158;p21"/>
+            <p:cNvPr id="169" name="Google Shape;169;p23"/>
             <p:cNvCxnSpPr/>
             <p:nvPr/>
           </p:nvCxnSpPr>
           <p:spPr>
-            <a:xfrm flipH="1">
-              <a:off x="8995516" y="0"/>
-              <a:ext cx="1" cy="6857894"/>
+            <a:xfrm>
+              <a:off x="8995518" y="0"/>
+              <a:ext cx="0" cy="6857828"/>
             </a:xfrm>
             <a:prstGeom prst="straightConnector1">
               <a:avLst/>
@@ -17383,14 +17383,14 @@
         </p:cxnSp>
         <p:cxnSp>
           <p:nvCxnSpPr>
-            <p:cNvPr id="159" name="Google Shape;159;p21"/>
+            <p:cNvPr id="170" name="Google Shape;170;p23"/>
             <p:cNvCxnSpPr/>
             <p:nvPr/>
           </p:nvCxnSpPr>
           <p:spPr>
-            <a:xfrm flipH="1">
-              <a:off x="9638160" y="0"/>
-              <a:ext cx="1" cy="6857894"/>
+            <a:xfrm>
+              <a:off x="9638162" y="0"/>
+              <a:ext cx="0" cy="6857828"/>
             </a:xfrm>
             <a:prstGeom prst="straightConnector1">
               <a:avLst/>
@@ -17409,14 +17409,14 @@
         </p:cxnSp>
         <p:cxnSp>
           <p:nvCxnSpPr>
-            <p:cNvPr id="160" name="Google Shape;160;p21"/>
+            <p:cNvPr id="171" name="Google Shape;171;p23"/>
             <p:cNvCxnSpPr/>
             <p:nvPr/>
           </p:nvCxnSpPr>
           <p:spPr>
-            <a:xfrm flipH="1">
-              <a:off x="10280697" y="0"/>
-              <a:ext cx="1" cy="6857894"/>
+            <a:xfrm>
+              <a:off x="10280699" y="0"/>
+              <a:ext cx="0" cy="6857828"/>
             </a:xfrm>
             <a:prstGeom prst="straightConnector1">
               <a:avLst/>
@@ -17435,14 +17435,14 @@
         </p:cxnSp>
         <p:cxnSp>
           <p:nvCxnSpPr>
-            <p:cNvPr id="161" name="Google Shape;161;p21"/>
+            <p:cNvPr id="172" name="Google Shape;172;p23"/>
             <p:cNvCxnSpPr/>
             <p:nvPr/>
           </p:nvCxnSpPr>
           <p:spPr>
-            <a:xfrm flipH="1">
-              <a:off x="10923355" y="0"/>
-              <a:ext cx="1" cy="6857894"/>
+            <a:xfrm>
+              <a:off x="10923356" y="0"/>
+              <a:ext cx="0" cy="6857828"/>
             </a:xfrm>
             <a:prstGeom prst="straightConnector1">
               <a:avLst/>
@@ -17461,28 +17461,28 @@
         </p:cxnSp>
         <p:grpSp>
           <p:nvGrpSpPr>
-            <p:cNvPr id="162" name="Google Shape;162;p21"/>
+            <p:cNvPr id="173" name="Google Shape;173;p23"/>
             <p:cNvGrpSpPr/>
             <p:nvPr/>
           </p:nvGrpSpPr>
           <p:grpSpPr>
             <a:xfrm>
-              <a:off x="11565987" y="0"/>
-              <a:ext cx="642649" cy="6857895"/>
-              <a:chOff x="-1" y="0"/>
-              <a:chExt cx="642647" cy="6857894"/>
+              <a:off x="11565989" y="0"/>
+              <a:ext cx="642644" cy="6857828"/>
+              <a:chOff x="1" y="0"/>
+              <a:chExt cx="642644" cy="6857828"/>
             </a:xfrm>
           </p:grpSpPr>
           <p:cxnSp>
             <p:nvCxnSpPr>
-              <p:cNvPr id="163" name="Google Shape;163;p21"/>
+              <p:cNvPr id="174" name="Google Shape;174;p23"/>
               <p:cNvCxnSpPr/>
               <p:nvPr/>
             </p:nvCxnSpPr>
             <p:spPr>
-              <a:xfrm flipH="1">
-                <a:off x="-1" y="0"/>
-                <a:ext cx="3" cy="6857894"/>
+              <a:xfrm>
+                <a:off x="1" y="0"/>
+                <a:ext cx="0" cy="6857828"/>
               </a:xfrm>
               <a:prstGeom prst="straightConnector1">
                 <a:avLst/>
@@ -17501,14 +17501,14 @@
           </p:cxnSp>
           <p:cxnSp>
             <p:nvCxnSpPr>
-              <p:cNvPr id="164" name="Google Shape;164;p21"/>
+              <p:cNvPr id="175" name="Google Shape;175;p23"/>
               <p:cNvCxnSpPr/>
               <p:nvPr/>
             </p:nvCxnSpPr>
             <p:spPr>
-              <a:xfrm flipH="1">
-                <a:off x="642644" y="0"/>
-                <a:ext cx="1" cy="6857894"/>
+              <a:xfrm>
+                <a:off x="642645" y="0"/>
+                <a:ext cx="0" cy="6857828"/>
               </a:xfrm>
               <a:prstGeom prst="straightConnector1">
                 <a:avLst/>
@@ -17529,14 +17529,14 @@
       </p:grpSp>
       <p:cxnSp>
         <p:nvCxnSpPr>
-          <p:cNvPr id="165" name="Google Shape;165;p21"/>
+          <p:cNvPr id="176" name="Google Shape;176;p23"/>
           <p:cNvCxnSpPr/>
           <p:nvPr/>
         </p:nvCxnSpPr>
         <p:spPr>
           <a:xfrm rot="10800000">
-            <a:off x="-25234" y="3718360"/>
-            <a:ext cx="12208496" cy="1"/>
+            <a:off x="-25233" y="3718362"/>
+            <a:ext cx="12208495" cy="0"/>
           </a:xfrm>
           <a:prstGeom prst="straightConnector1">
             <a:avLst/>
@@ -17555,14 +17555,14 @@
       </p:cxnSp>
       <p:cxnSp>
         <p:nvCxnSpPr>
-          <p:cNvPr id="166" name="Google Shape;166;p21"/>
+          <p:cNvPr id="177" name="Google Shape;177;p23"/>
           <p:cNvCxnSpPr/>
           <p:nvPr/>
         </p:nvCxnSpPr>
         <p:spPr>
           <a:xfrm rot="10800000">
-            <a:off x="-25234" y="4367764"/>
-            <a:ext cx="12208496" cy="1"/>
+            <a:off x="-25233" y="4367765"/>
+            <a:ext cx="12208495" cy="0"/>
           </a:xfrm>
           <a:prstGeom prst="straightConnector1">
             <a:avLst/>
@@ -17581,14 +17581,14 @@
       </p:cxnSp>
       <p:cxnSp>
         <p:nvCxnSpPr>
-          <p:cNvPr id="167" name="Google Shape;167;p21"/>
+          <p:cNvPr id="178" name="Google Shape;178;p23"/>
           <p:cNvCxnSpPr/>
           <p:nvPr/>
         </p:nvCxnSpPr>
         <p:spPr>
           <a:xfrm rot="10800000">
-            <a:off x="-25234" y="5017093"/>
-            <a:ext cx="12208496" cy="1"/>
+            <a:off x="-25233" y="5017094"/>
+            <a:ext cx="12208495" cy="0"/>
           </a:xfrm>
           <a:prstGeom prst="straightConnector1">
             <a:avLst/>
@@ -17607,14 +17607,14 @@
       </p:cxnSp>
       <p:cxnSp>
         <p:nvCxnSpPr>
-          <p:cNvPr id="168" name="Google Shape;168;p21"/>
+          <p:cNvPr id="179" name="Google Shape;179;p23"/>
           <p:cNvCxnSpPr/>
           <p:nvPr/>
         </p:nvCxnSpPr>
         <p:spPr>
           <a:xfrm rot="10800000">
-            <a:off x="-25234" y="5666496"/>
-            <a:ext cx="12208496" cy="1"/>
+            <a:off x="-25233" y="5666497"/>
+            <a:ext cx="12208495" cy="0"/>
           </a:xfrm>
           <a:prstGeom prst="straightConnector1">
             <a:avLst/>
@@ -17633,14 +17633,14 @@
       </p:cxnSp>
       <p:cxnSp>
         <p:nvCxnSpPr>
-          <p:cNvPr id="169" name="Google Shape;169;p21"/>
+          <p:cNvPr id="180" name="Google Shape;180;p23"/>
           <p:cNvCxnSpPr/>
           <p:nvPr/>
         </p:nvCxnSpPr>
         <p:spPr>
           <a:xfrm rot="10800000">
-            <a:off x="-25234" y="6315793"/>
-            <a:ext cx="12208496" cy="1"/>
+            <a:off x="-25233" y="6315794"/>
+            <a:ext cx="12208495" cy="0"/>
           </a:xfrm>
           <a:prstGeom prst="straightConnector1">
             <a:avLst/>
@@ -17659,7 +17659,7 @@
       </p:cxnSp>
       <p:sp>
         <p:nvSpPr>
-          <p:cNvPr id="170" name="Google Shape;170;p21"/>
+          <p:cNvPr id="181" name="Google Shape;181;p23"/>
           <p:cNvSpPr txBox="1"/>
           <p:nvPr>
             <p:ph type="title"/>
@@ -17668,7 +17668,7 @@
         <p:spPr>
           <a:xfrm>
             <a:off x="1916919" y="1768556"/>
-            <a:ext cx="8344993" cy="2597536"/>
+            <a:ext cx="8344991" cy="2597535"/>
           </a:xfrm>
           <a:prstGeom prst="rect">
             <a:avLst/>
@@ -17851,7 +17851,7 @@
       </p:sp>
       <p:sp>
         <p:nvSpPr>
-          <p:cNvPr id="171" name="Google Shape;171;p21"/>
+          <p:cNvPr id="182" name="Google Shape;182;p23"/>
           <p:cNvSpPr txBox="1"/>
           <p:nvPr>
             <p:ph idx="12" type="sldNum"/>
@@ -17860,7 +17860,7 @@
         <p:spPr>
           <a:xfrm>
             <a:off x="11652438" y="6343529"/>
-            <a:ext cx="169330" cy="169330"/>
+            <a:ext cx="169196" cy="163996"/>
           </a:xfrm>
           <a:prstGeom prst="rect">
             <a:avLst/>
@@ -18387,7 +18387,7 @@
   <p:cSld name="BLANK_1_1_1_1_1_1_1_1_1_1_1">
     <p:spTree>
       <p:nvGrpSpPr>
-        <p:cNvPr id="172" name="Shape 172"/>
+        <p:cNvPr id="183" name="Shape 183"/>
         <p:cNvGrpSpPr/>
         <p:nvPr/>
       </p:nvGrpSpPr>
@@ -18401,7 +18401,7 @@
       </p:grpSpPr>
       <p:sp>
         <p:nvSpPr>
-          <p:cNvPr id="173" name="Google Shape;173;p22"/>
+          <p:cNvPr id="184" name="Google Shape;184;p24"/>
           <p:cNvSpPr txBox="1"/>
           <p:nvPr>
             <p:ph idx="1" type="body"/>
@@ -18410,7 +18410,7 @@
         <p:spPr>
           <a:xfrm>
             <a:off x="6052947" y="2307264"/>
-            <a:ext cx="5767457" cy="603586"/>
+            <a:ext cx="5767456" cy="603585"/>
           </a:xfrm>
           <a:prstGeom prst="rect">
             <a:avLst/>
@@ -18597,7 +18597,7 @@
       </p:sp>
       <p:sp>
         <p:nvSpPr>
-          <p:cNvPr id="174" name="Google Shape;174;p22"/>
+          <p:cNvPr id="185" name="Google Shape;185;p24"/>
           <p:cNvSpPr txBox="1"/>
           <p:nvPr>
             <p:ph type="title"/>
@@ -18606,7 +18606,7 @@
         <p:spPr>
           <a:xfrm>
             <a:off x="369989" y="1412865"/>
-            <a:ext cx="5725858" cy="3737908"/>
+            <a:ext cx="5725857" cy="3737906"/>
           </a:xfrm>
           <a:prstGeom prst="rect">
             <a:avLst/>
@@ -18781,7 +18781,7 @@
       </p:sp>
       <p:pic>
         <p:nvPicPr>
-          <p:cNvPr descr="Logo-white.pngGoogle Shape;115;p9" id="175" name="Google Shape;175;p22"/>
+          <p:cNvPr descr="Logo-white.pngGoogle Shape;115;p9" id="186" name="Google Shape;186;p24"/>
           <p:cNvPicPr preferRelativeResize="0"/>
           <p:nvPr/>
         </p:nvPicPr>
@@ -18808,7 +18808,7 @@
       </p:pic>
       <p:sp>
         <p:nvSpPr>
-          <p:cNvPr id="176" name="Google Shape;176;p22"/>
+          <p:cNvPr id="187" name="Google Shape;187;p24"/>
           <p:cNvSpPr txBox="1"/>
           <p:nvPr>
             <p:ph idx="12" type="sldNum"/>
@@ -18817,7 +18817,7 @@
         <p:spPr>
           <a:xfrm>
             <a:off x="11652438" y="6343529"/>
-            <a:ext cx="169330" cy="169330"/>
+            <a:ext cx="169196" cy="163996"/>
           </a:xfrm>
           <a:prstGeom prst="rect">
             <a:avLst/>
@@ -21068,7 +21068,7 @@
     </p:bg>
     <p:spTree>
       <p:nvGrpSpPr>
-        <p:cNvPr id="50" name="Shape 50"/>
+        <p:cNvPr id="61" name="Shape 61"/>
         <p:cNvGrpSpPr/>
         <p:nvPr/>
       </p:nvGrpSpPr>
@@ -21082,7 +21082,7 @@
       </p:grpSpPr>
       <p:sp>
         <p:nvSpPr>
-          <p:cNvPr id="51" name="Google Shape;51;p13"/>
+          <p:cNvPr id="62" name="Google Shape;62;p15"/>
           <p:cNvSpPr txBox="1"/>
           <p:nvPr>
             <p:ph type="title"/>
@@ -21091,7 +21091,7 @@
         <p:spPr>
           <a:xfrm>
             <a:off x="726948" y="369989"/>
-            <a:ext cx="10737731" cy="795981"/>
+            <a:ext cx="10737731" cy="795980"/>
           </a:xfrm>
           <a:prstGeom prst="rect">
             <a:avLst/>
@@ -21106,7 +21106,7 @@
             <a:normAutofit/>
           </a:bodyPr>
           <a:lstStyle>
-            <a:lvl1pPr lvl="0" marR="0" rtl="0" algn="ctr">
+            <a:lvl1pPr lvl="0" marR="0" algn="ctr">
               <a:lnSpc>
                 <a:spcPct val="90000"/>
               </a:lnSpc>
@@ -21132,7 +21132,7 @@
                 <a:sym typeface="Montserrat SemiBold"/>
               </a:defRPr>
             </a:lvl1pPr>
-            <a:lvl2pPr lvl="1" marR="0" rtl="0" algn="ctr">
+            <a:lvl2pPr lvl="1" marR="0" algn="ctr">
               <a:lnSpc>
                 <a:spcPct val="90000"/>
               </a:lnSpc>
@@ -21158,7 +21158,7 @@
                 <a:sym typeface="Montserrat SemiBold"/>
               </a:defRPr>
             </a:lvl2pPr>
-            <a:lvl3pPr lvl="2" marR="0" rtl="0" algn="ctr">
+            <a:lvl3pPr lvl="2" marR="0" algn="ctr">
               <a:lnSpc>
                 <a:spcPct val="90000"/>
               </a:lnSpc>
@@ -21184,7 +21184,7 @@
                 <a:sym typeface="Montserrat SemiBold"/>
               </a:defRPr>
             </a:lvl3pPr>
-            <a:lvl4pPr lvl="3" marR="0" rtl="0" algn="ctr">
+            <a:lvl4pPr lvl="3" marR="0" algn="ctr">
               <a:lnSpc>
                 <a:spcPct val="90000"/>
               </a:lnSpc>
@@ -21210,7 +21210,7 @@
                 <a:sym typeface="Montserrat SemiBold"/>
               </a:defRPr>
             </a:lvl4pPr>
-            <a:lvl5pPr lvl="4" marR="0" rtl="0" algn="ctr">
+            <a:lvl5pPr lvl="4" marR="0" algn="ctr">
               <a:lnSpc>
                 <a:spcPct val="90000"/>
               </a:lnSpc>
@@ -21236,7 +21236,7 @@
                 <a:sym typeface="Montserrat SemiBold"/>
               </a:defRPr>
             </a:lvl5pPr>
-            <a:lvl6pPr lvl="5" marR="0" rtl="0" algn="ctr">
+            <a:lvl6pPr lvl="5" marR="0" algn="ctr">
               <a:lnSpc>
                 <a:spcPct val="90000"/>
               </a:lnSpc>
@@ -21262,7 +21262,7 @@
                 <a:sym typeface="Montserrat SemiBold"/>
               </a:defRPr>
             </a:lvl6pPr>
-            <a:lvl7pPr lvl="6" marR="0" rtl="0" algn="ctr">
+            <a:lvl7pPr lvl="6" marR="0" algn="ctr">
               <a:lnSpc>
                 <a:spcPct val="90000"/>
               </a:lnSpc>
@@ -21288,7 +21288,7 @@
                 <a:sym typeface="Montserrat SemiBold"/>
               </a:defRPr>
             </a:lvl7pPr>
-            <a:lvl8pPr lvl="7" marR="0" rtl="0" algn="ctr">
+            <a:lvl8pPr lvl="7" marR="0" algn="ctr">
               <a:lnSpc>
                 <a:spcPct val="90000"/>
               </a:lnSpc>
@@ -21314,7 +21314,7 @@
                 <a:sym typeface="Montserrat SemiBold"/>
               </a:defRPr>
             </a:lvl8pPr>
-            <a:lvl9pPr lvl="8" marR="0" rtl="0" algn="ctr">
+            <a:lvl9pPr lvl="8" marR="0" algn="ctr">
               <a:lnSpc>
                 <a:spcPct val="90000"/>
               </a:lnSpc>
@@ -21346,7 +21346,7 @@
       </p:sp>
       <p:sp>
         <p:nvSpPr>
-          <p:cNvPr id="52" name="Google Shape;52;p13"/>
+          <p:cNvPr id="63" name="Google Shape;63;p15"/>
           <p:cNvSpPr txBox="1"/>
           <p:nvPr>
             <p:ph idx="1" type="body"/>
@@ -21355,7 +21355,7 @@
         <p:spPr>
           <a:xfrm>
             <a:off x="609585" y="1600160"/>
-            <a:ext cx="10972526" cy="5257668"/>
+            <a:ext cx="10972526" cy="5257468"/>
           </a:xfrm>
           <a:prstGeom prst="rect">
             <a:avLst/>
@@ -21370,7 +21370,7 @@
             <a:noAutofit/>
           </a:bodyPr>
           <a:lstStyle>
-            <a:lvl1pPr indent="-298450" lvl="0" marL="457200" marR="0" rtl="0" algn="l">
+            <a:lvl1pPr indent="-298450" lvl="0" marL="457200" marR="0" algn="l">
               <a:lnSpc>
                 <a:spcPct val="100000"/>
               </a:lnSpc>
@@ -21396,7 +21396,7 @@
                 <a:sym typeface="Montserrat"/>
               </a:defRPr>
             </a:lvl1pPr>
-            <a:lvl2pPr indent="-298450" lvl="1" marL="914400" marR="0" rtl="0" algn="l">
+            <a:lvl2pPr indent="-298450" lvl="1" marL="914400" marR="0" algn="l">
               <a:lnSpc>
                 <a:spcPct val="100000"/>
               </a:lnSpc>
@@ -21422,7 +21422,7 @@
                 <a:sym typeface="Montserrat"/>
               </a:defRPr>
             </a:lvl2pPr>
-            <a:lvl3pPr indent="-298450" lvl="2" marL="1371600" marR="0" rtl="0" algn="l">
+            <a:lvl3pPr indent="-298450" lvl="2" marL="1371600" marR="0" algn="l">
               <a:lnSpc>
                 <a:spcPct val="100000"/>
               </a:lnSpc>
@@ -21448,7 +21448,7 @@
                 <a:sym typeface="Montserrat"/>
               </a:defRPr>
             </a:lvl3pPr>
-            <a:lvl4pPr indent="-298450" lvl="3" marL="1828800" marR="0" rtl="0" algn="l">
+            <a:lvl4pPr indent="-298450" lvl="3" marL="1828800" marR="0" algn="l">
               <a:lnSpc>
                 <a:spcPct val="100000"/>
               </a:lnSpc>
@@ -21474,7 +21474,7 @@
                 <a:sym typeface="Montserrat"/>
               </a:defRPr>
             </a:lvl4pPr>
-            <a:lvl5pPr indent="-298450" lvl="4" marL="2286000" marR="0" rtl="0" algn="l">
+            <a:lvl5pPr indent="-298450" lvl="4" marL="2286000" marR="0" algn="l">
               <a:lnSpc>
                 <a:spcPct val="100000"/>
               </a:lnSpc>
@@ -21500,7 +21500,7 @@
                 <a:sym typeface="Montserrat"/>
               </a:defRPr>
             </a:lvl5pPr>
-            <a:lvl6pPr indent="-298450" lvl="5" marL="2743200" marR="0" rtl="0" algn="l">
+            <a:lvl6pPr indent="-298450" lvl="5" marL="2743200" marR="0" algn="l">
               <a:lnSpc>
                 <a:spcPct val="100000"/>
               </a:lnSpc>
@@ -21526,7 +21526,7 @@
                 <a:sym typeface="Montserrat"/>
               </a:defRPr>
             </a:lvl6pPr>
-            <a:lvl7pPr indent="-298450" lvl="6" marL="3200400" marR="0" rtl="0" algn="l">
+            <a:lvl7pPr indent="-298450" lvl="6" marL="3200400" marR="0" algn="l">
               <a:lnSpc>
                 <a:spcPct val="100000"/>
               </a:lnSpc>
@@ -21552,7 +21552,7 @@
                 <a:sym typeface="Montserrat"/>
               </a:defRPr>
             </a:lvl7pPr>
-            <a:lvl8pPr indent="-298450" lvl="7" marL="3657600" marR="0" rtl="0" algn="l">
+            <a:lvl8pPr indent="-298450" lvl="7" marL="3657600" marR="0" algn="l">
               <a:lnSpc>
                 <a:spcPct val="100000"/>
               </a:lnSpc>
@@ -21578,7 +21578,7 @@
                 <a:sym typeface="Montserrat"/>
               </a:defRPr>
             </a:lvl8pPr>
-            <a:lvl9pPr indent="-298450" lvl="8" marL="4114800" marR="0" rtl="0" algn="l">
+            <a:lvl9pPr indent="-298450" lvl="8" marL="4114800" marR="0" algn="l">
               <a:lnSpc>
                 <a:spcPct val="100000"/>
               </a:lnSpc>
@@ -21610,7 +21610,7 @@
       </p:sp>
       <p:sp>
         <p:nvSpPr>
-          <p:cNvPr id="53" name="Google Shape;53;p13"/>
+          <p:cNvPr id="64" name="Google Shape;64;p15"/>
           <p:cNvSpPr txBox="1"/>
           <p:nvPr>
             <p:ph idx="12" type="sldNum"/>
@@ -21619,7 +21619,7 @@
         <p:spPr>
           <a:xfrm>
             <a:off x="5892653" y="6169928"/>
-            <a:ext cx="2844729" cy="372525"/>
+            <a:ext cx="2844729" cy="369191"/>
           </a:xfrm>
           <a:prstGeom prst="rect">
             <a:avLst/>
@@ -21634,7 +21634,7 @@
             <a:spAutoFit/>
           </a:bodyPr>
           <a:lstStyle>
-            <a:lvl1pPr indent="0" lvl="0" marL="0" marR="0" rtl="0" algn="r">
+            <a:lvl1pPr indent="0" lvl="0" marL="0" marR="0" algn="r">
               <a:lnSpc>
                 <a:spcPct val="100000"/>
               </a:lnSpc>
@@ -21660,7 +21660,7 @@
                 <a:sym typeface="Arial"/>
               </a:defRPr>
             </a:lvl1pPr>
-            <a:lvl2pPr indent="0" lvl="1" marL="0" marR="0" rtl="0" algn="r">
+            <a:lvl2pPr indent="0" lvl="1" marL="0" marR="0" algn="r">
               <a:lnSpc>
                 <a:spcPct val="100000"/>
               </a:lnSpc>
@@ -21686,7 +21686,7 @@
                 <a:sym typeface="Arial"/>
               </a:defRPr>
             </a:lvl2pPr>
-            <a:lvl3pPr indent="0" lvl="2" marL="0" marR="0" rtl="0" algn="r">
+            <a:lvl3pPr indent="0" lvl="2" marL="0" marR="0" algn="r">
               <a:lnSpc>
                 <a:spcPct val="100000"/>
               </a:lnSpc>
@@ -21712,7 +21712,7 @@
                 <a:sym typeface="Arial"/>
               </a:defRPr>
             </a:lvl3pPr>
-            <a:lvl4pPr indent="0" lvl="3" marL="0" marR="0" rtl="0" algn="r">
+            <a:lvl4pPr indent="0" lvl="3" marL="0" marR="0" algn="r">
               <a:lnSpc>
                 <a:spcPct val="100000"/>
               </a:lnSpc>
@@ -21738,7 +21738,7 @@
                 <a:sym typeface="Arial"/>
               </a:defRPr>
             </a:lvl4pPr>
-            <a:lvl5pPr indent="0" lvl="4" marL="0" marR="0" rtl="0" algn="r">
+            <a:lvl5pPr indent="0" lvl="4" marL="0" marR="0" algn="r">
               <a:lnSpc>
                 <a:spcPct val="100000"/>
               </a:lnSpc>
@@ -21764,7 +21764,7 @@
                 <a:sym typeface="Arial"/>
               </a:defRPr>
             </a:lvl5pPr>
-            <a:lvl6pPr indent="0" lvl="5" marL="0" marR="0" rtl="0" algn="r">
+            <a:lvl6pPr indent="0" lvl="5" marL="0" marR="0" algn="r">
               <a:lnSpc>
                 <a:spcPct val="100000"/>
               </a:lnSpc>
@@ -21790,7 +21790,7 @@
                 <a:sym typeface="Arial"/>
               </a:defRPr>
             </a:lvl6pPr>
-            <a:lvl7pPr indent="0" lvl="6" marL="0" marR="0" rtl="0" algn="r">
+            <a:lvl7pPr indent="0" lvl="6" marL="0" marR="0" algn="r">
               <a:lnSpc>
                 <a:spcPct val="100000"/>
               </a:lnSpc>
@@ -21816,7 +21816,7 @@
                 <a:sym typeface="Arial"/>
               </a:defRPr>
             </a:lvl7pPr>
-            <a:lvl8pPr indent="0" lvl="7" marL="0" marR="0" rtl="0" algn="r">
+            <a:lvl8pPr indent="0" lvl="7" marL="0" marR="0" algn="r">
               <a:lnSpc>
                 <a:spcPct val="100000"/>
               </a:lnSpc>
@@ -21842,7 +21842,7 @@
                 <a:sym typeface="Arial"/>
               </a:defRPr>
             </a:lvl8pPr>
-            <a:lvl9pPr indent="0" lvl="8" marL="0" marR="0" rtl="0" algn="r">
+            <a:lvl9pPr indent="0" lvl="8" marL="0" marR="0" algn="r">
               <a:lnSpc>
                 <a:spcPct val="100000"/>
               </a:lnSpc>
@@ -21891,25 +21891,25 @@
   </p:cSld>
   <p:clrMap accent1="accent1" accent2="accent2" accent3="accent3" accent4="accent4" accent5="accent5" accent6="accent6" bg1="lt1" bg2="dk2" tx1="dk1" tx2="lt2" folHlink="folHlink" hlink="hlink"/>
   <p:sldLayoutIdLst>
-    <p:sldLayoutId id="2147483659" r:id="rId1"/>
-    <p:sldLayoutId id="2147483660" r:id="rId2"/>
-    <p:sldLayoutId id="2147483661" r:id="rId3"/>
-    <p:sldLayoutId id="2147483662" r:id="rId4"/>
-    <p:sldLayoutId id="2147483663" r:id="rId5"/>
-    <p:sldLayoutId id="2147483664" r:id="rId6"/>
-    <p:sldLayoutId id="2147483665" r:id="rId7"/>
-    <p:sldLayoutId id="2147483666" r:id="rId8"/>
-    <p:sldLayoutId id="2147483667" r:id="rId9"/>
-    <p:sldLayoutId id="2147483668" r:id="rId10"/>
-    <p:sldLayoutId id="2147483669" r:id="rId11"/>
-    <p:sldLayoutId id="2147483670" r:id="rId12"/>
-    <p:sldLayoutId id="2147483671" r:id="rId13"/>
-    <p:sldLayoutId id="2147483672" r:id="rId14"/>
-    <p:sldLayoutId id="2147483673" r:id="rId15"/>
-    <p:sldLayoutId id="2147483674" r:id="rId16"/>
-    <p:sldLayoutId id="2147483675" r:id="rId17"/>
-    <p:sldLayoutId id="2147483676" r:id="rId18"/>
-    <p:sldLayoutId id="2147483677" r:id="rId19"/>
+    <p:sldLayoutId id="2147483661" r:id="rId1"/>
+    <p:sldLayoutId id="2147483662" r:id="rId2"/>
+    <p:sldLayoutId id="2147483663" r:id="rId3"/>
+    <p:sldLayoutId id="2147483664" r:id="rId4"/>
+    <p:sldLayoutId id="2147483665" r:id="rId5"/>
+    <p:sldLayoutId id="2147483666" r:id="rId6"/>
+    <p:sldLayoutId id="2147483667" r:id="rId7"/>
+    <p:sldLayoutId id="2147483668" r:id="rId8"/>
+    <p:sldLayoutId id="2147483669" r:id="rId9"/>
+    <p:sldLayoutId id="2147483670" r:id="rId10"/>
+    <p:sldLayoutId id="2147483671" r:id="rId11"/>
+    <p:sldLayoutId id="2147483672" r:id="rId12"/>
+    <p:sldLayoutId id="2147483673" r:id="rId13"/>
+    <p:sldLayoutId id="2147483674" r:id="rId14"/>
+    <p:sldLayoutId id="2147483675" r:id="rId15"/>
+    <p:sldLayoutId id="2147483676" r:id="rId16"/>
+    <p:sldLayoutId id="2147483677" r:id="rId17"/>
+    <p:sldLayoutId id="2147483678" r:id="rId18"/>
+    <p:sldLayoutId id="2147483679" r:id="rId19"/>
   </p:sldLayoutIdLst>
   <p:hf dt="0" ftr="0" hdr="0" sldNum="0"/>
   <p:txStyles>
@@ -22609,7 +22609,7 @@
   <p:cSld>
     <p:spTree>
       <p:nvGrpSpPr>
-        <p:cNvPr id="409" name="Shape 409"/>
+        <p:cNvPr id="269" name="Shape 269"/>
         <p:cNvGrpSpPr/>
         <p:nvPr/>
       </p:nvGrpSpPr>
@@ -22623,14 +22623,14 @@
       </p:grpSpPr>
       <p:sp>
         <p:nvSpPr>
-          <p:cNvPr id="410" name="Google Shape;410;p55"/>
+          <p:cNvPr id="270" name="Google Shape;270;p35"/>
           <p:cNvSpPr txBox="1"/>
           <p:nvPr/>
         </p:nvSpPr>
         <p:spPr>
           <a:xfrm>
             <a:off x="386922" y="1395101"/>
-            <a:ext cx="11417850" cy="548626"/>
+            <a:ext cx="11417714" cy="548626"/>
           </a:xfrm>
           <a:prstGeom prst="rect">
             <a:avLst/>
@@ -22681,14 +22681,14 @@
       </p:sp>
       <p:sp>
         <p:nvSpPr>
-          <p:cNvPr id="411" name="Google Shape;411;p55"/>
+          <p:cNvPr id="271" name="Google Shape;271;p35"/>
           <p:cNvSpPr txBox="1"/>
           <p:nvPr/>
         </p:nvSpPr>
         <p:spPr>
           <a:xfrm>
             <a:off x="369989" y="554985"/>
-            <a:ext cx="11451715" cy="821867"/>
+            <a:ext cx="11451714" cy="821979"/>
           </a:xfrm>
           <a:prstGeom prst="rect">
             <a:avLst/>
@@ -22739,14 +22739,14 @@
       </p:sp>
       <p:sp>
         <p:nvSpPr>
-          <p:cNvPr id="412" name="Google Shape;412;p55"/>
+          <p:cNvPr descr="{{ library_capture }}" id="272" name="Google Shape;272;p35"/>
           <p:cNvSpPr/>
           <p:nvPr/>
         </p:nvSpPr>
         <p:spPr>
           <a:xfrm>
             <a:off x="964733" y="2024880"/>
-            <a:ext cx="6886717" cy="4387950"/>
+            <a:ext cx="6886628" cy="4387890"/>
           </a:xfrm>
           <a:prstGeom prst="rect">
             <a:avLst/>
@@ -22805,14 +22805,14 @@
       </p:sp>
       <p:sp>
         <p:nvSpPr>
-          <p:cNvPr id="413" name="Google Shape;413;p55"/>
+          <p:cNvPr id="273" name="Google Shape;273;p35"/>
           <p:cNvSpPr txBox="1"/>
           <p:nvPr/>
         </p:nvSpPr>
         <p:spPr>
           <a:xfrm>
             <a:off x="8432682" y="2020280"/>
-            <a:ext cx="3478602" cy="1641434"/>
+            <a:ext cx="3478713" cy="1641959"/>
           </a:xfrm>
           <a:prstGeom prst="rect">
             <a:avLst/>

</xml_diff>